<commit_message>
Update Level 2 summary PPT: correct test/preflight counts, add work-energy and timestep slides
</commit_message>
<xml_diff>
--- a/Level2_同步波形优化_总结报告.pptx
+++ b/Level2_同步波形优化_总结报告.pptx
@@ -18,6 +18,8 @@
     <p:sldId id="266" r:id="rId17"/>
     <p:sldId id="267" r:id="rId18"/>
     <p:sldId id="268" r:id="rId19"/>
+    <p:sldId id="269" r:id="rId20"/>
+    <p:sldId id="270" r:id="rId21"/>
   </p:sldIdLst>
   <p:sldSz cx="12191695" cy="6858000" type="screen4x3"/>
   <p:notesSz cx="6858000" cy="9144000"/>
@@ -3285,7 +3287,7 @@
                   <a:srgbClr val="88A8C8"/>
                 </a:solidFill>
               </a:rPr>
-              <a:t>70 项测试全部通过 · 257 个优化候选 · 2000 shots 独立验证</a:t>
+              <a:t>88 项测试全部通过 · 257 个优化候选 · 2000 shots 独立验证</a:t>
             </a:r>
           </a:p>
         </p:txBody>
@@ -3713,7 +3715,7 @@
                   <a:srgbClr val="222A35"/>
                 </a:solidFill>
               </a:rPr>
-              <a:t>  128 shots 配对标签</a:t>
+              <a:t>  MC 配对标签翻转率</a:t>
             </a:r>
           </a:p>
           <a:p>
@@ -3724,7 +3726,7 @@
                   <a:srgbClr val="222A35"/>
                 </a:solidFill>
               </a:rPr>
-              <a:t>  不一致率 ≤2%</a:t>
+              <a:t>  实测 = 0</a:t>
             </a:r>
           </a:p>
           <a:p>
@@ -3790,7 +3792,7 @@
                   <a:srgbClr val="222A35"/>
                 </a:solidFill>
               </a:rPr>
-              <a:t>本次：10/10 全部通过</a:t>
+              <a:t>本次：9/9 关键检查通过</a:t>
             </a:r>
           </a:p>
           <a:p>
@@ -3801,7 +3803,7 @@
                   <a:srgbClr val="222A35"/>
                 </a:solidFill>
               </a:rPr>
-              <a:t>（336 s，含旧测试）</a:t>
+              <a:t>（284 s，含 88 项旧测试）</a:t>
             </a:r>
           </a:p>
         </p:txBody>
@@ -3930,7 +3932,7 @@
                   <a:srgbClr val="DDE8F5"/>
                 </a:solidFill>
               </a:rPr>
-              <a:t>70 项测试全部通过</a:t>
+              <a:t>88 项测试全部通过</a:t>
             </a:r>
           </a:p>
         </p:txBody>
@@ -4209,7 +4211,7 @@
                   <a:srgbClr val="222A35"/>
                 </a:solidFill>
               </a:rPr>
-              <a:t>→ 70 passed</a:t>
+              <a:t>→ 88 passed</a:t>
             </a:r>
           </a:p>
           <a:p>
@@ -4300,6 +4302,380 @@
 </file>
 
 <file path=ppt/slides/slide13.xml><?xml version="1.0" encoding="utf-8"?>
+<p:sld xmlns:a="http://schemas.openxmlformats.org/drawingml/2006/main" xmlns:p="http://schemas.openxmlformats.org/presentationml/2006/main" xmlns:r="http://schemas.openxmlformats.org/officeDocument/2006/relationships">
+  <p:cSld>
+    <p:spTree>
+      <p:nvGrpSpPr>
+        <p:cNvPr id="1" name=""/>
+        <p:cNvGrpSpPr/>
+        <p:nvPr/>
+      </p:nvGrpSpPr>
+      <p:grpSpPr/>
+      <p:sp>
+        <p:nvSpPr>
+          <p:cNvPr id="2" name="Rectangle 1"/>
+          <p:cNvSpPr/>
+          <p:nvPr/>
+        </p:nvSpPr>
+        <p:spPr>
+          <a:xfrm>
+            <a:off x="0" y="0"/>
+            <a:ext cx="12191695" cy="868680"/>
+          </a:xfrm>
+          <a:prstGeom prst="rect">
+            <a:avLst/>
+          </a:prstGeom>
+          <a:solidFill>
+            <a:srgbClr val="1F77B4"/>
+          </a:solidFill>
+          <a:ln>
+            <a:noFill/>
+          </a:ln>
+        </p:spPr>
+        <p:style>
+          <a:lnRef idx="1">
+            <a:schemeClr val="accent1"/>
+          </a:lnRef>
+          <a:fillRef idx="3">
+            <a:schemeClr val="accent1"/>
+          </a:fillRef>
+          <a:effectRef idx="2">
+            <a:schemeClr val="accent1"/>
+          </a:effectRef>
+          <a:fontRef idx="minor">
+            <a:schemeClr val="lt1"/>
+          </a:fontRef>
+        </p:style>
+        <p:txBody>
+          <a:bodyPr rtlCol="0" anchor="ctr"/>
+          <a:lstStyle/>
+          <a:p>
+            <a:pPr algn="ctr"/>
+          </a:p>
+        </p:txBody>
+      </p:sp>
+      <p:sp>
+        <p:nvSpPr>
+          <p:cNvPr id="3" name="TextBox 2"/>
+          <p:cNvSpPr txBox="1"/>
+          <p:nvPr/>
+        </p:nvSpPr>
+        <p:spPr>
+          <a:xfrm>
+            <a:off x="457200" y="109728"/>
+            <a:ext cx="11338560" cy="548640"/>
+          </a:xfrm>
+          <a:prstGeom prst="rect">
+            <a:avLst/>
+          </a:prstGeom>
+          <a:noFill/>
+        </p:spPr>
+        <p:txBody>
+          <a:bodyPr wrap="square">
+            <a:spAutoFit/>
+          </a:bodyPr>
+          <a:lstStyle/>
+          <a:p>
+            <a:pPr algn="l"/>
+            <a:r>
+              <a:rPr sz="2600" b="1">
+                <a:solidFill>
+                  <a:srgbClr val="FFFFFF"/>
+                </a:solidFill>
+              </a:rPr>
+              <a:t>功-能核算：转移期间外部做功的显式验证</a:t>
+            </a:r>
+          </a:p>
+        </p:txBody>
+      </p:sp>
+      <p:sp>
+        <p:nvSpPr>
+          <p:cNvPr id="4" name="TextBox 3"/>
+          <p:cNvSpPr txBox="1"/>
+          <p:nvPr/>
+        </p:nvSpPr>
+        <p:spPr>
+          <a:xfrm>
+            <a:off x="502920" y="566928"/>
+            <a:ext cx="11247120" cy="320040"/>
+          </a:xfrm>
+          <a:prstGeom prst="rect">
+            <a:avLst/>
+          </a:prstGeom>
+          <a:noFill/>
+        </p:spPr>
+        <p:txBody>
+          <a:bodyPr wrap="square">
+            <a:spAutoFit/>
+          </a:bodyPr>
+          <a:lstStyle/>
+          <a:p>
+            <a:pPr algn="l"/>
+            <a:r>
+              <a:rPr sz="1300" b="0">
+                <a:solidFill>
+                  <a:srgbClr val="DDE8F5"/>
+                </a:solidFill>
+              </a:rPr>
+              <a:t>demo 输出 · 多条代表轨迹</a:t>
+            </a:r>
+          </a:p>
+        </p:txBody>
+      </p:sp>
+      <p:pic>
+        <p:nvPicPr>
+          <p:cNvPr id="5" name="Picture 4" descr="work_energy_balance.png"/>
+          <p:cNvPicPr>
+            <a:picLocks noChangeAspect="1"/>
+          </p:cNvPicPr>
+          <p:nvPr/>
+        </p:nvPicPr>
+        <p:blipFill>
+          <a:blip r:embed="rId2"/>
+          <a:stretch>
+            <a:fillRect/>
+          </a:stretch>
+        </p:blipFill>
+        <p:spPr>
+          <a:xfrm>
+            <a:off x="1970042" y="914400"/>
+            <a:ext cx="8221435" cy="4846320"/>
+          </a:xfrm>
+          <a:prstGeom prst="rect">
+            <a:avLst/>
+          </a:prstGeom>
+        </p:spPr>
+      </p:pic>
+      <p:sp>
+        <p:nvSpPr>
+          <p:cNvPr id="6" name="TextBox 5"/>
+          <p:cNvSpPr txBox="1"/>
+          <p:nvPr/>
+        </p:nvSpPr>
+        <p:spPr>
+          <a:xfrm>
+            <a:off x="640080" y="5897880"/>
+            <a:ext cx="10972800" cy="731520"/>
+          </a:xfrm>
+          <a:prstGeom prst="rect">
+            <a:avLst/>
+          </a:prstGeom>
+          <a:noFill/>
+        </p:spPr>
+        <p:txBody>
+          <a:bodyPr wrap="square">
+            <a:spAutoFit/>
+          </a:bodyPr>
+          <a:lstStyle/>
+          <a:p>
+            <a:pPr algn="l"/>
+            <a:r>
+              <a:rPr sz="1300" b="0">
+                <a:solidFill>
+                  <a:srgbClr val="666666"/>
+                </a:solidFill>
+              </a:rPr>
+              <a:t>黑线 ΔE(t) 与绿线外部总功 W_ext(t) 逐点重合，残差 R_W（红线）远小于 1e-3·D_SLM；深度功在降深段把能量取走，移动功在移动段注入能量，两者符号与量级符合物理直觉。</a:t>
+            </a:r>
+          </a:p>
+        </p:txBody>
+      </p:sp>
+    </p:spTree>
+  </p:cSld>
+  <p:clrMapOvr>
+    <a:masterClrMapping/>
+  </p:clrMapOvr>
+</p:sld>
+</file>
+
+<file path=ppt/slides/slide14.xml><?xml version="1.0" encoding="utf-8"?>
+<p:sld xmlns:a="http://schemas.openxmlformats.org/drawingml/2006/main" xmlns:p="http://schemas.openxmlformats.org/presentationml/2006/main" xmlns:r="http://schemas.openxmlformats.org/officeDocument/2006/relationships">
+  <p:cSld>
+    <p:spTree>
+      <p:nvGrpSpPr>
+        <p:cNvPr id="1" name=""/>
+        <p:cNvGrpSpPr/>
+        <p:nvPr/>
+      </p:nvGrpSpPr>
+      <p:grpSpPr/>
+      <p:sp>
+        <p:nvSpPr>
+          <p:cNvPr id="2" name="Rectangle 1"/>
+          <p:cNvSpPr/>
+          <p:nvPr/>
+        </p:nvSpPr>
+        <p:spPr>
+          <a:xfrm>
+            <a:off x="0" y="0"/>
+            <a:ext cx="12191695" cy="868680"/>
+          </a:xfrm>
+          <a:prstGeom prst="rect">
+            <a:avLst/>
+          </a:prstGeom>
+          <a:solidFill>
+            <a:srgbClr val="1F77B4"/>
+          </a:solidFill>
+          <a:ln>
+            <a:noFill/>
+          </a:ln>
+        </p:spPr>
+        <p:style>
+          <a:lnRef idx="1">
+            <a:schemeClr val="accent1"/>
+          </a:lnRef>
+          <a:fillRef idx="3">
+            <a:schemeClr val="accent1"/>
+          </a:fillRef>
+          <a:effectRef idx="2">
+            <a:schemeClr val="accent1"/>
+          </a:effectRef>
+          <a:fontRef idx="minor">
+            <a:schemeClr val="lt1"/>
+          </a:fontRef>
+        </p:style>
+        <p:txBody>
+          <a:bodyPr rtlCol="0" anchor="ctr"/>
+          <a:lstStyle/>
+          <a:p>
+            <a:pPr algn="ctr"/>
+          </a:p>
+        </p:txBody>
+      </p:sp>
+      <p:sp>
+        <p:nvSpPr>
+          <p:cNvPr id="3" name="TextBox 2"/>
+          <p:cNvSpPr txBox="1"/>
+          <p:nvPr/>
+        </p:nvSpPr>
+        <p:spPr>
+          <a:xfrm>
+            <a:off x="457200" y="109728"/>
+            <a:ext cx="11338560" cy="548640"/>
+          </a:xfrm>
+          <a:prstGeom prst="rect">
+            <a:avLst/>
+          </a:prstGeom>
+          <a:noFill/>
+        </p:spPr>
+        <p:txBody>
+          <a:bodyPr wrap="square">
+            <a:spAutoFit/>
+          </a:bodyPr>
+          <a:lstStyle/>
+          <a:p>
+            <a:pPr algn="l"/>
+            <a:r>
+              <a:rPr sz="2600" b="1">
+                <a:solidFill>
+                  <a:srgbClr val="FFFFFF"/>
+                </a:solidFill>
+              </a:rPr>
+              <a:t>步长收敛与俘获标签稳定性</a:t>
+            </a:r>
+          </a:p>
+        </p:txBody>
+      </p:sp>
+      <p:sp>
+        <p:nvSpPr>
+          <p:cNvPr id="4" name="TextBox 3"/>
+          <p:cNvSpPr txBox="1"/>
+          <p:nvPr/>
+        </p:nvSpPr>
+        <p:spPr>
+          <a:xfrm>
+            <a:off x="502920" y="566928"/>
+            <a:ext cx="11247120" cy="320040"/>
+          </a:xfrm>
+          <a:prstGeom prst="rect">
+            <a:avLst/>
+          </a:prstGeom>
+          <a:noFill/>
+        </p:spPr>
+        <p:txBody>
+          <a:bodyPr wrap="square">
+            <a:spAutoFit/>
+          </a:bodyPr>
+          <a:lstStyle/>
+          <a:p>
+            <a:pPr algn="l"/>
+            <a:r>
+              <a:rPr sz="1300" b="0">
+                <a:solidFill>
+                  <a:srgbClr val="DDE8F5"/>
+                </a:solidFill>
+              </a:rPr>
+              <a:t>demo 输出 · dt = 0.10 / 0.05 / 0.025 μs</a:t>
+            </a:r>
+          </a:p>
+        </p:txBody>
+      </p:sp>
+      <p:pic>
+        <p:nvPicPr>
+          <p:cNvPr id="5" name="Picture 4" descr="timestep_convergence.png"/>
+          <p:cNvPicPr>
+            <a:picLocks noChangeAspect="1"/>
+          </p:cNvPicPr>
+          <p:nvPr/>
+        </p:nvPicPr>
+        <p:blipFill>
+          <a:blip r:embed="rId2"/>
+          <a:stretch>
+            <a:fillRect/>
+          </a:stretch>
+        </p:blipFill>
+        <p:spPr>
+          <a:xfrm>
+            <a:off x="228600" y="996695"/>
+            <a:ext cx="11704320" cy="4681728"/>
+          </a:xfrm>
+          <a:prstGeom prst="rect">
+            <a:avLst/>
+          </a:prstGeom>
+        </p:spPr>
+      </p:pic>
+      <p:sp>
+        <p:nvSpPr>
+          <p:cNvPr id="6" name="TextBox 5"/>
+          <p:cNvSpPr txBox="1"/>
+          <p:nvPr/>
+        </p:nvSpPr>
+        <p:spPr>
+          <a:xfrm>
+            <a:off x="640080" y="5897880"/>
+            <a:ext cx="10972800" cy="731520"/>
+          </a:xfrm>
+          <a:prstGeom prst="rect">
+            <a:avLst/>
+          </a:prstGeom>
+          <a:noFill/>
+        </p:spPr>
+        <p:txBody>
+          <a:bodyPr wrap="square">
+            <a:spAutoFit/>
+          </a:bodyPr>
+          <a:lstStyle/>
+          <a:p>
+            <a:pPr algn="l"/>
+            <a:r>
+              <a:rPr sz="1300" b="0">
+                <a:solidFill>
+                  <a:srgbClr val="666666"/>
+                </a:solidFill>
+              </a:rPr>
+              <a:t>左：末态能量最大偏差随 dt 减小呈二阶下降（对数坐标）；右：三种波形俘获标签翻转率 ≈ 0，说明 dt=0.05 μs 的验证结果不是积分误差的产物。</a:t>
+            </a:r>
+          </a:p>
+        </p:txBody>
+      </p:sp>
+    </p:spTree>
+  </p:cSld>
+  <p:clrMapOvr>
+    <a:masterClrMapping/>
+  </p:clrMapOvr>
+</p:sld>
+</file>
+
+<file path=ppt/slides/slide15.xml><?xml version="1.0" encoding="utf-8"?>
 <p:sld xmlns:a="http://schemas.openxmlformats.org/drawingml/2006/main" xmlns:p="http://schemas.openxmlformats.org/presentationml/2006/main" xmlns:r="http://schemas.openxmlformats.org/officeDocument/2006/relationships">
   <p:cSld>
     <p:spTree>

</xml_diff>

<commit_message>
Fix Level 2 PPT factual counts: preflight 10/10, LHS 192 + refinement 65; regenerate PPTX
</commit_message>
<xml_diff>
--- a/Level2_同步波形优化_总结报告.pptx
+++ b/Level2_同步波形优化_总结报告.pptx
@@ -3792,7 +3792,7 @@
                   <a:srgbClr val="222A35"/>
                 </a:solidFill>
               </a:rPr>
-              <a:t>本次：9/9 关键检查通过</a:t>
+              <a:t>本次：10/10 检查全部通过</a:t>
             </a:r>
           </a:p>
           <a:p>
@@ -6532,7 +6532,7 @@
                   <a:srgbClr val="222A35"/>
                 </a:solidFill>
               </a:rPr>
-              <a:t>LHS 探索 257 候选</a:t>
+              <a:t>LHS 探索 192 候选</a:t>
             </a:r>
           </a:p>
           <a:p>
@@ -6543,7 +6543,7 @@
                   <a:srgbClr val="222A35"/>
                 </a:solidFill>
               </a:rPr>
-              <a:t>（有效229/无效28/失败0）</a:t>
+              <a:t>（后续入围/精修/样条 65）</a:t>
             </a:r>
           </a:p>
           <a:p>

</xml_diff>

<commit_message>
Backup snapshot: level2_joint_transfer (含 mean-heating 扩展) 与 Level2B 产物, Level 2C 开工前基线
</commit_message>
<xml_diff>
--- a/Level2_同步波形优化_总结报告.pptx
+++ b/Level2_同步波形优化_总结报告.pptx
@@ -15,11 +15,6 @@
     <p:sldId id="263" r:id="rId14"/>
     <p:sldId id="264" r:id="rId15"/>
     <p:sldId id="265" r:id="rId16"/>
-    <p:sldId id="266" r:id="rId17"/>
-    <p:sldId id="267" r:id="rId18"/>
-    <p:sldId id="268" r:id="rId19"/>
-    <p:sldId id="269" r:id="rId20"/>
-    <p:sldId id="270" r:id="rId21"/>
   </p:sldIdLst>
   <p:sldSz cx="12191695" cy="6858000" type="screen4x3"/>
   <p:notesSz cx="6858000" cy="9144000"/>
@@ -3153,8 +3148,8 @@
         </p:nvSpPr>
         <p:spPr>
           <a:xfrm>
-            <a:off x="914400" y="1920240"/>
-            <a:ext cx="10332720" cy="1097280"/>
+            <a:off x="914400" y="1417320"/>
+            <a:ext cx="10332720" cy="457200"/>
           </a:xfrm>
           <a:prstGeom prst="rect">
             <a:avLst/>
@@ -3169,7 +3164,7 @@
           <a:p>
             <a:pPr algn="ctr"/>
             <a:r>
-              <a:rPr sz="3000" b="0">
+              <a:rPr sz="1800" b="0">
                 <a:solidFill>
                   <a:srgbClr val="9EC5E8"/>
                 </a:solidFill>
@@ -3187,8 +3182,8 @@
         </p:nvSpPr>
         <p:spPr>
           <a:xfrm>
-            <a:off x="914400" y="2743200"/>
-            <a:ext cx="10332720" cy="1280160"/>
+            <a:off x="914400" y="2057400"/>
+            <a:ext cx="10332720" cy="914400"/>
           </a:xfrm>
           <a:prstGeom prst="rect">
             <a:avLst/>
@@ -3208,32 +3203,134 @@
                   <a:srgbClr val="FFFFFF"/>
                 </a:solidFill>
               </a:rPr>
-              <a:t>Level 2：同步移动-降深波形优化</a:t>
-            </a:r>
-          </a:p>
+              <a:t>Level 2：同步波形优化</a:t>
+            </a:r>
+          </a:p>
+        </p:txBody>
+      </p:sp>
+      <p:sp>
+        <p:nvSpPr>
+          <p:cNvPr id="5" name="TextBox 4"/>
+          <p:cNvSpPr txBox="1"/>
+          <p:nvPr/>
+        </p:nvSpPr>
+        <p:spPr>
+          <a:xfrm>
+            <a:off x="914400" y="3063240"/>
+            <a:ext cx="10332720" cy="457200"/>
+          </a:xfrm>
+          <a:prstGeom prst="rect">
+            <a:avLst/>
+          </a:prstGeom>
+          <a:noFill/>
+        </p:spPr>
+        <p:txBody>
+          <a:bodyPr wrap="square">
+            <a:spAutoFit/>
+          </a:bodyPr>
+          <a:lstStyle/>
           <a:p>
             <a:pPr algn="ctr"/>
             <a:r>
-              <a:rPr sz="4000" b="1">
+              <a:rPr sz="1700" b="0">
+                <a:solidFill>
+                  <a:srgbClr val="BBD3E8"/>
+                </a:solidFill>
+              </a:rPr>
+              <a:t>600 μs 顺序基线 → 400 μs 同步重叠波形的鲁棒蒙特卡洛验证</a:t>
+            </a:r>
+          </a:p>
+        </p:txBody>
+      </p:sp>
+      <p:sp>
+        <p:nvSpPr>
+          <p:cNvPr id="6" name="Rounded Rectangle 5"/>
+          <p:cNvSpPr/>
+          <p:nvPr/>
+        </p:nvSpPr>
+        <p:spPr>
+          <a:xfrm>
+            <a:off x="1417320" y="3977639"/>
+            <a:ext cx="2514600" cy="1234440"/>
+          </a:xfrm>
+          <a:prstGeom prst="roundRect">
+            <a:avLst/>
+          </a:prstGeom>
+          <a:solidFill>
+            <a:srgbClr val="1B3A5C"/>
+          </a:solidFill>
+          <a:ln>
+            <a:solidFill>
+              <a:srgbClr val="2C5A8C"/>
+            </a:solidFill>
+          </a:ln>
+        </p:spPr>
+        <p:style>
+          <a:lnRef idx="1">
+            <a:schemeClr val="accent1"/>
+          </a:lnRef>
+          <a:fillRef idx="3">
+            <a:schemeClr val="accent1"/>
+          </a:fillRef>
+          <a:effectRef idx="2">
+            <a:schemeClr val="accent1"/>
+          </a:effectRef>
+          <a:fontRef idx="minor">
+            <a:schemeClr val="lt1"/>
+          </a:fontRef>
+        </p:style>
+        <p:txBody>
+          <a:bodyPr rtlCol="0" anchor="ctr"/>
+          <a:lstStyle/>
+          <a:p>
+            <a:pPr algn="ctr"/>
+          </a:p>
+        </p:txBody>
+      </p:sp>
+      <p:sp>
+        <p:nvSpPr>
+          <p:cNvPr id="7" name="TextBox 6"/>
+          <p:cNvSpPr txBox="1"/>
+          <p:nvPr/>
+        </p:nvSpPr>
+        <p:spPr>
+          <a:xfrm>
+            <a:off x="1417320" y="4114800"/>
+            <a:ext cx="2514600" cy="548640"/>
+          </a:xfrm>
+          <a:prstGeom prst="rect">
+            <a:avLst/>
+          </a:prstGeom>
+          <a:noFill/>
+        </p:spPr>
+        <p:txBody>
+          <a:bodyPr wrap="square">
+            <a:spAutoFit/>
+          </a:bodyPr>
+          <a:lstStyle/>
+          <a:p>
+            <a:pPr algn="ctr"/>
+            <a:r>
+              <a:rPr sz="2600" b="1">
                 <a:solidFill>
                   <a:srgbClr val="FFFFFF"/>
                 </a:solidFill>
               </a:rPr>
-              <a:t>与鲁棒蒙特卡洛验证</a:t>
-            </a:r>
-          </a:p>
-        </p:txBody>
-      </p:sp>
-      <p:sp>
-        <p:nvSpPr>
-          <p:cNvPr id="5" name="TextBox 4"/>
+              <a:t>2000 / 2000</a:t>
+            </a:r>
+          </a:p>
+        </p:txBody>
+      </p:sp>
+      <p:sp>
+        <p:nvSpPr>
+          <p:cNvPr id="8" name="TextBox 7"/>
           <p:cNvSpPr txBox="1"/>
           <p:nvPr/>
         </p:nvSpPr>
         <p:spPr>
           <a:xfrm>
-            <a:off x="914400" y="4937760"/>
-            <a:ext cx="10332720" cy="457200"/>
+            <a:off x="1417320" y="4736592"/>
+            <a:ext cx="2514600" cy="365760"/>
           </a:xfrm>
           <a:prstGeom prst="rect">
             <a:avLst/>
@@ -3248,25 +3345,251 @@
           <a:p>
             <a:pPr algn="ctr"/>
             <a:r>
-              <a:rPr sz="1600" b="0">
+              <a:rPr sz="1200" b="0">
                 <a:solidFill>
-                  <a:srgbClr val="BBD3E8"/>
+                  <a:srgbClr val="9EC5E8"/>
                 </a:solidFill>
               </a:rPr>
-              <a:t>600 μs 顺序基线 vs 400 μs 压缩基线 vs 400 μs 优化同步波形</a:t>
-            </a:r>
-          </a:p>
-        </p:txBody>
-      </p:sp>
-      <p:sp>
-        <p:nvSpPr>
-          <p:cNvPr id="6" name="TextBox 5"/>
+              <a:t>独立验证俘获率</a:t>
+            </a:r>
+          </a:p>
+        </p:txBody>
+      </p:sp>
+      <p:sp>
+        <p:nvSpPr>
+          <p:cNvPr id="9" name="Rounded Rectangle 8"/>
+          <p:cNvSpPr/>
+          <p:nvPr/>
+        </p:nvSpPr>
+        <p:spPr>
+          <a:xfrm>
+            <a:off x="4846320" y="3977639"/>
+            <a:ext cx="2514600" cy="1234440"/>
+          </a:xfrm>
+          <a:prstGeom prst="roundRect">
+            <a:avLst/>
+          </a:prstGeom>
+          <a:solidFill>
+            <a:srgbClr val="1B3A5C"/>
+          </a:solidFill>
+          <a:ln>
+            <a:solidFill>
+              <a:srgbClr val="2C5A8C"/>
+            </a:solidFill>
+          </a:ln>
+        </p:spPr>
+        <p:style>
+          <a:lnRef idx="1">
+            <a:schemeClr val="accent1"/>
+          </a:lnRef>
+          <a:fillRef idx="3">
+            <a:schemeClr val="accent1"/>
+          </a:fillRef>
+          <a:effectRef idx="2">
+            <a:schemeClr val="accent1"/>
+          </a:effectRef>
+          <a:fontRef idx="minor">
+            <a:schemeClr val="lt1"/>
+          </a:fontRef>
+        </p:style>
+        <p:txBody>
+          <a:bodyPr rtlCol="0" anchor="ctr"/>
+          <a:lstStyle/>
+          <a:p>
+            <a:pPr algn="ctr"/>
+          </a:p>
+        </p:txBody>
+      </p:sp>
+      <p:sp>
+        <p:nvSpPr>
+          <p:cNvPr id="10" name="TextBox 9"/>
           <p:cNvSpPr txBox="1"/>
           <p:nvPr/>
         </p:nvSpPr>
         <p:spPr>
           <a:xfrm>
-            <a:off x="914400" y="6035040"/>
+            <a:off x="4846320" y="4114800"/>
+            <a:ext cx="2514600" cy="548640"/>
+          </a:xfrm>
+          <a:prstGeom prst="rect">
+            <a:avLst/>
+          </a:prstGeom>
+          <a:noFill/>
+        </p:spPr>
+        <p:txBody>
+          <a:bodyPr wrap="square">
+            <a:spAutoFit/>
+          </a:bodyPr>
+          <a:lstStyle/>
+          <a:p>
+            <a:pPr algn="ctr"/>
+            <a:r>
+              <a:rPr sz="2600" b="1">
+                <a:solidFill>
+                  <a:srgbClr val="FFFFFF"/>
+                </a:solidFill>
+              </a:rPr>
+              <a:t>257</a:t>
+            </a:r>
+          </a:p>
+        </p:txBody>
+      </p:sp>
+      <p:sp>
+        <p:nvSpPr>
+          <p:cNvPr id="11" name="TextBox 10"/>
+          <p:cNvSpPr txBox="1"/>
+          <p:nvPr/>
+        </p:nvSpPr>
+        <p:spPr>
+          <a:xfrm>
+            <a:off x="4846320" y="4736592"/>
+            <a:ext cx="2514600" cy="365760"/>
+          </a:xfrm>
+          <a:prstGeom prst="rect">
+            <a:avLst/>
+          </a:prstGeom>
+          <a:noFill/>
+        </p:spPr>
+        <p:txBody>
+          <a:bodyPr wrap="square">
+            <a:spAutoFit/>
+          </a:bodyPr>
+          <a:lstStyle/>
+          <a:p>
+            <a:pPr algn="ctr"/>
+            <a:r>
+              <a:rPr sz="1200" b="0">
+                <a:solidFill>
+                  <a:srgbClr val="9EC5E8"/>
+                </a:solidFill>
+              </a:rPr>
+              <a:t>优化候选（192 LHS + 65 精修）</a:t>
+            </a:r>
+          </a:p>
+        </p:txBody>
+      </p:sp>
+      <p:sp>
+        <p:nvSpPr>
+          <p:cNvPr id="12" name="Rounded Rectangle 11"/>
+          <p:cNvSpPr/>
+          <p:nvPr/>
+        </p:nvSpPr>
+        <p:spPr>
+          <a:xfrm>
+            <a:off x="8275320" y="3977639"/>
+            <a:ext cx="2514600" cy="1234440"/>
+          </a:xfrm>
+          <a:prstGeom prst="roundRect">
+            <a:avLst/>
+          </a:prstGeom>
+          <a:solidFill>
+            <a:srgbClr val="1B3A5C"/>
+          </a:solidFill>
+          <a:ln>
+            <a:solidFill>
+              <a:srgbClr val="2C5A8C"/>
+            </a:solidFill>
+          </a:ln>
+        </p:spPr>
+        <p:style>
+          <a:lnRef idx="1">
+            <a:schemeClr val="accent1"/>
+          </a:lnRef>
+          <a:fillRef idx="3">
+            <a:schemeClr val="accent1"/>
+          </a:fillRef>
+          <a:effectRef idx="2">
+            <a:schemeClr val="accent1"/>
+          </a:effectRef>
+          <a:fontRef idx="minor">
+            <a:schemeClr val="lt1"/>
+          </a:fontRef>
+        </p:style>
+        <p:txBody>
+          <a:bodyPr rtlCol="0" anchor="ctr"/>
+          <a:lstStyle/>
+          <a:p>
+            <a:pPr algn="ctr"/>
+          </a:p>
+        </p:txBody>
+      </p:sp>
+      <p:sp>
+        <p:nvSpPr>
+          <p:cNvPr id="13" name="TextBox 12"/>
+          <p:cNvSpPr txBox="1"/>
+          <p:nvPr/>
+        </p:nvSpPr>
+        <p:spPr>
+          <a:xfrm>
+            <a:off x="8275320" y="4114800"/>
+            <a:ext cx="2514600" cy="548640"/>
+          </a:xfrm>
+          <a:prstGeom prst="rect">
+            <a:avLst/>
+          </a:prstGeom>
+          <a:noFill/>
+        </p:spPr>
+        <p:txBody>
+          <a:bodyPr wrap="square">
+            <a:spAutoFit/>
+          </a:bodyPr>
+          <a:lstStyle/>
+          <a:p>
+            <a:pPr algn="ctr"/>
+            <a:r>
+              <a:rPr sz="2600" b="1">
+                <a:solidFill>
+                  <a:srgbClr val="FFFFFF"/>
+                </a:solidFill>
+              </a:rPr>
+              <a:t>10 / 10</a:t>
+            </a:r>
+          </a:p>
+        </p:txBody>
+      </p:sp>
+      <p:sp>
+        <p:nvSpPr>
+          <p:cNvPr id="14" name="TextBox 13"/>
+          <p:cNvSpPr txBox="1"/>
+          <p:nvPr/>
+        </p:nvSpPr>
+        <p:spPr>
+          <a:xfrm>
+            <a:off x="8275320" y="4736592"/>
+            <a:ext cx="2514600" cy="365760"/>
+          </a:xfrm>
+          <a:prstGeom prst="rect">
+            <a:avLst/>
+          </a:prstGeom>
+          <a:noFill/>
+        </p:spPr>
+        <p:txBody>
+          <a:bodyPr wrap="square">
+            <a:spAutoFit/>
+          </a:bodyPr>
+          <a:lstStyle/>
+          <a:p>
+            <a:pPr algn="ctr"/>
+            <a:r>
+              <a:rPr sz="1200" b="0">
+                <a:solidFill>
+                  <a:srgbClr val="9EC5E8"/>
+                </a:solidFill>
+              </a:rPr>
+              <a:t>preflight 预检查通过</a:t>
+            </a:r>
+          </a:p>
+        </p:txBody>
+      </p:sp>
+      <p:sp>
+        <p:nvSpPr>
+          <p:cNvPr id="15" name="TextBox 14"/>
+          <p:cNvSpPr txBox="1"/>
+          <p:nvPr/>
+        </p:nvSpPr>
+        <p:spPr>
+          <a:xfrm>
+            <a:off x="914400" y="5897880"/>
             <a:ext cx="10332720" cy="365760"/>
           </a:xfrm>
           <a:prstGeom prst="rect">
@@ -3287,7 +3610,7 @@
                   <a:srgbClr val="88A8C8"/>
                 </a:solidFill>
               </a:rPr>
-              <a:t>88 项测试全部通过 · 257 个优化候选 · 2000 shots 独立验证</a:t>
+              <a:t>结论预览：5 μK 工况处于饱和区，三波形俘获率均 100%，如实报告</a:t>
             </a:r>
           </a:p>
         </p:txBody>
@@ -3319,7 +3642,7 @@
         <p:spPr>
           <a:xfrm>
             <a:off x="0" y="0"/>
-            <a:ext cx="12191695" cy="868680"/>
+            <a:ext cx="12191695" cy="786384"/>
           </a:xfrm>
           <a:prstGeom prst="rect">
             <a:avLst/>
@@ -3361,8 +3684,8 @@
         </p:nvSpPr>
         <p:spPr>
           <a:xfrm>
-            <a:off x="457200" y="109728"/>
-            <a:ext cx="11338560" cy="548640"/>
+            <a:off x="457200" y="91440"/>
+            <a:ext cx="11338560" cy="603504"/>
           </a:xfrm>
           <a:prstGeom prst="rect">
             <a:avLst/>
@@ -3375,21 +3698,20 @@
           </a:bodyPr>
           <a:lstStyle/>
           <a:p>
-            <a:pPr algn="l"/>
-            <a:r>
-              <a:rPr sz="2600" b="1">
+            <a:r>
+              <a:rPr sz="2500" b="1">
                 <a:solidFill>
                   <a:srgbClr val="FFFFFF"/>
                 </a:solidFill>
               </a:rPr>
-              <a:t>鲁棒性敏感性（冻结参数后不再调优）</a:t>
+              <a:t>同时长移动方案：峰值速度低者胜</a:t>
             </a:r>
           </a:p>
         </p:txBody>
       </p:sp>
       <p:pic>
         <p:nvPicPr>
-          <p:cNvPr id="4" name="Picture 3" descr="07_鲁棒性.png"/>
+          <p:cNvPr id="4" name="Picture 3" descr="s14_同时长方案对比.png"/>
           <p:cNvPicPr>
             <a:picLocks noChangeAspect="1"/>
           </p:cNvPicPr>
@@ -3403,8 +3725,8 @@
         </p:blipFill>
         <p:spPr>
           <a:xfrm>
-            <a:off x="228600" y="1524358"/>
-            <a:ext cx="11704320" cy="3717842"/>
+            <a:off x="274319" y="990785"/>
+            <a:ext cx="11640312" cy="4739269"/>
           </a:xfrm>
           <a:prstGeom prst="rect">
             <a:avLst/>
@@ -3420,7 +3742,7 @@
         <p:spPr>
           <a:xfrm>
             <a:off x="640080" y="5989320"/>
-            <a:ext cx="10972800" cy="640080"/>
+            <a:ext cx="10881360" cy="548640"/>
           </a:xfrm>
           <a:prstGeom prst="rect">
             <a:avLst/>
@@ -3433,1559 +3755,14 @@
           </a:bodyPr>
           <a:lstStyle/>
           <a:p>
-            <a:pPr algn="l"/>
-            <a:r>
-              <a:rPr sz="1300" b="0">
+            <a:pPr algn="ctr"/>
+            <a:r>
+              <a:rPr sz="1400">
                 <a:solidFill>
                   <a:srgbClr val="666666"/>
                 </a:solidFill>
               </a:rPr>
-              <a:t>温度 3/5/7/10 μK、末端对准偏差 ±0.10 μm（各 500 shots）下俘获率保持 100%；步长 0.10→0.025 μs 连续量收敛、俘获标签翻转≈0。</a:t>
-            </a:r>
-          </a:p>
-        </p:txBody>
-      </p:sp>
-    </p:spTree>
-  </p:cSld>
-  <p:clrMapOvr>
-    <a:masterClrMapping/>
-  </p:clrMapOvr>
-</p:sld>
-</file>
-
-<file path=ppt/slides/slide11.xml><?xml version="1.0" encoding="utf-8"?>
-<p:sld xmlns:a="http://schemas.openxmlformats.org/drawingml/2006/main" xmlns:p="http://schemas.openxmlformats.org/presentationml/2006/main" xmlns:r="http://schemas.openxmlformats.org/officeDocument/2006/relationships">
-  <p:cSld>
-    <p:spTree>
-      <p:nvGrpSpPr>
-        <p:cNvPr id="1" name=""/>
-        <p:cNvGrpSpPr/>
-        <p:nvPr/>
-      </p:nvGrpSpPr>
-      <p:grpSpPr/>
-      <p:sp>
-        <p:nvSpPr>
-          <p:cNvPr id="2" name="Rectangle 1"/>
-          <p:cNvSpPr/>
-          <p:nvPr/>
-        </p:nvSpPr>
-        <p:spPr>
-          <a:xfrm>
-            <a:off x="0" y="0"/>
-            <a:ext cx="12191695" cy="868680"/>
-          </a:xfrm>
-          <a:prstGeom prst="rect">
-            <a:avLst/>
-          </a:prstGeom>
-          <a:solidFill>
-            <a:srgbClr val="1F77B4"/>
-          </a:solidFill>
-          <a:ln>
-            <a:noFill/>
-          </a:ln>
-        </p:spPr>
-        <p:style>
-          <a:lnRef idx="1">
-            <a:schemeClr val="accent1"/>
-          </a:lnRef>
-          <a:fillRef idx="3">
-            <a:schemeClr val="accent1"/>
-          </a:fillRef>
-          <a:effectRef idx="2">
-            <a:schemeClr val="accent1"/>
-          </a:effectRef>
-          <a:fontRef idx="minor">
-            <a:schemeClr val="lt1"/>
-          </a:fontRef>
-        </p:style>
-        <p:txBody>
-          <a:bodyPr rtlCol="0" anchor="ctr"/>
-          <a:lstStyle/>
-          <a:p>
-            <a:pPr algn="ctr"/>
-          </a:p>
-        </p:txBody>
-      </p:sp>
-      <p:sp>
-        <p:nvSpPr>
-          <p:cNvPr id="3" name="TextBox 2"/>
-          <p:cNvSpPr txBox="1"/>
-          <p:nvPr/>
-        </p:nvSpPr>
-        <p:spPr>
-          <a:xfrm>
-            <a:off x="457200" y="109728"/>
-            <a:ext cx="11338560" cy="548640"/>
-          </a:xfrm>
-          <a:prstGeom prst="rect">
-            <a:avLst/>
-          </a:prstGeom>
-          <a:noFill/>
-        </p:spPr>
-        <p:txBody>
-          <a:bodyPr wrap="square">
-            <a:spAutoFit/>
-          </a:bodyPr>
-          <a:lstStyle/>
-          <a:p>
-            <a:pPr algn="l"/>
-            <a:r>
-              <a:rPr sz="2600" b="1">
-                <a:solidFill>
-                  <a:srgbClr val="FFFFFF"/>
-                </a:solidFill>
-              </a:rPr>
-              <a:t>Preflight：不过关不得启动优化</a:t>
-            </a:r>
-          </a:p>
-        </p:txBody>
-      </p:sp>
-      <p:pic>
-        <p:nvPicPr>
-          <p:cNvPr id="4" name="Picture 3" descr="08_预检查清单.png"/>
-          <p:cNvPicPr>
-            <a:picLocks noChangeAspect="1"/>
-          </p:cNvPicPr>
-          <p:nvPr/>
-        </p:nvPicPr>
-        <p:blipFill>
-          <a:blip r:embed="rId2"/>
-          <a:stretch>
-            <a:fillRect/>
-          </a:stretch>
-        </p:blipFill>
-        <p:spPr>
-          <a:xfrm>
-            <a:off x="228600" y="1401493"/>
-            <a:ext cx="8138160" cy="4695092"/>
-          </a:xfrm>
-          <a:prstGeom prst="rect">
-            <a:avLst/>
-          </a:prstGeom>
-        </p:spPr>
-      </p:pic>
-      <p:sp>
-        <p:nvSpPr>
-          <p:cNvPr id="5" name="Rectangle 4"/>
-          <p:cNvSpPr/>
-          <p:nvPr/>
-        </p:nvSpPr>
-        <p:spPr>
-          <a:xfrm>
-            <a:off x="8503920" y="1097280"/>
-            <a:ext cx="3383280" cy="4937760"/>
-          </a:xfrm>
-          <a:prstGeom prst="rect">
-            <a:avLst/>
-          </a:prstGeom>
-          <a:solidFill>
-            <a:srgbClr val="FDEEEE"/>
-          </a:solidFill>
-          <a:ln>
-            <a:solidFill>
-              <a:srgbClr val="D62728"/>
-            </a:solidFill>
-          </a:ln>
-        </p:spPr>
-        <p:style>
-          <a:lnRef idx="1">
-            <a:schemeClr val="accent1"/>
-          </a:lnRef>
-          <a:fillRef idx="3">
-            <a:schemeClr val="accent1"/>
-          </a:fillRef>
-          <a:effectRef idx="2">
-            <a:schemeClr val="accent1"/>
-          </a:effectRef>
-          <a:fontRef idx="minor">
-            <a:schemeClr val="lt1"/>
-          </a:fontRef>
-        </p:style>
-        <p:txBody>
-          <a:bodyPr rtlCol="0" anchor="ctr"/>
-          <a:lstStyle/>
-          <a:p>
-            <a:pPr algn="ctr"/>
-          </a:p>
-        </p:txBody>
-      </p:sp>
-      <p:sp>
-        <p:nvSpPr>
-          <p:cNvPr id="6" name="TextBox 5"/>
-          <p:cNvSpPr txBox="1"/>
-          <p:nvPr/>
-        </p:nvSpPr>
-        <p:spPr>
-          <a:xfrm>
-            <a:off x="8686800" y="1325880"/>
-            <a:ext cx="3017520" cy="4572000"/>
-          </a:xfrm>
-          <a:prstGeom prst="rect">
-            <a:avLst/>
-          </a:prstGeom>
-          <a:noFill/>
-        </p:spPr>
-        <p:txBody>
-          <a:bodyPr wrap="square">
-            <a:spAutoFit/>
-          </a:bodyPr>
-          <a:lstStyle/>
-          <a:p>
-            <a:pPr algn="l"/>
-            <a:r>
-              <a:rPr sz="1300" b="0">
-                <a:solidFill>
-                  <a:srgbClr val="222A35"/>
-                </a:solidFill>
-              </a:rPr>
-              <a:t>为什么重要？</a:t>
-            </a:r>
-          </a:p>
-          <a:p>
-            <a:pPr algn="l"/>
-            <a:r>
-              <a:rPr sz="1300" b="0">
-                <a:solidFill>
-                  <a:srgbClr val="222A35"/>
-                </a:solidFill>
-              </a:rPr>
-              <a:t/>
-            </a:r>
-          </a:p>
-          <a:p>
-            <a:pPr algn="l"/>
-            <a:r>
-              <a:rPr sz="1300" b="0">
-                <a:solidFill>
-                  <a:srgbClr val="222A35"/>
-                </a:solidFill>
-              </a:rPr>
-              <a:t>· 时变势中 E(t) 变化</a:t>
-            </a:r>
-          </a:p>
-          <a:p>
-            <a:pPr algn="l"/>
-            <a:r>
-              <a:rPr sz="1300" b="0">
-                <a:solidFill>
-                  <a:srgbClr val="222A35"/>
-                </a:solidFill>
-              </a:rPr>
-              <a:t>  ≠ 积分器漂移，</a:t>
-            </a:r>
-          </a:p>
-          <a:p>
-            <a:pPr algn="l"/>
-            <a:r>
-              <a:rPr sz="1300" b="0">
-                <a:solidFill>
-                  <a:srgbClr val="222A35"/>
-                </a:solidFill>
-              </a:rPr>
-              <a:t>  必须用功-能关系区分</a:t>
-            </a:r>
-          </a:p>
-          <a:p>
-            <a:pPr algn="l"/>
-            <a:r>
-              <a:rPr sz="1300" b="0">
-                <a:solidFill>
-                  <a:srgbClr val="222A35"/>
-                </a:solidFill>
-              </a:rPr>
-              <a:t/>
-            </a:r>
-          </a:p>
-          <a:p>
-            <a:pPr algn="l"/>
-            <a:r>
-              <a:rPr sz="1300" b="0">
-                <a:solidFill>
-                  <a:srgbClr val="222A35"/>
-                </a:solidFill>
-              </a:rPr>
-              <a:t>· 步长减半收敛 +</a:t>
-            </a:r>
-          </a:p>
-          <a:p>
-            <a:pPr algn="l"/>
-            <a:r>
-              <a:rPr sz="1300" b="0">
-                <a:solidFill>
-                  <a:srgbClr val="222A35"/>
-                </a:solidFill>
-              </a:rPr>
-              <a:t>  MC 配对标签翻转率</a:t>
-            </a:r>
-          </a:p>
-          <a:p>
-            <a:pPr algn="l"/>
-            <a:r>
-              <a:rPr sz="1300" b="0">
-                <a:solidFill>
-                  <a:srgbClr val="222A35"/>
-                </a:solidFill>
-              </a:rPr>
-              <a:t>  实测 = 0</a:t>
-            </a:r>
-          </a:p>
-          <a:p>
-            <a:pPr algn="l"/>
-            <a:r>
-              <a:rPr sz="1300" b="0">
-                <a:solidFill>
-                  <a:srgbClr val="222A35"/>
-                </a:solidFill>
-              </a:rPr>
-              <a:t/>
-            </a:r>
-          </a:p>
-          <a:p>
-            <a:pPr algn="l"/>
-            <a:r>
-              <a:rPr sz="1300" b="0">
-                <a:solidFill>
-                  <a:srgbClr val="222A35"/>
-                </a:solidFill>
-              </a:rPr>
-              <a:t>· 任一项失败即终止，</a:t>
-            </a:r>
-          </a:p>
-          <a:p>
-            <a:pPr algn="l"/>
-            <a:r>
-              <a:rPr sz="1300" b="0">
-                <a:solidFill>
-                  <a:srgbClr val="222A35"/>
-                </a:solidFill>
-              </a:rPr>
-              <a:t>  不会生成『看似完整』</a:t>
-            </a:r>
-          </a:p>
-          <a:p>
-            <a:pPr algn="l"/>
-            <a:r>
-              <a:rPr sz="1300" b="0">
-                <a:solidFill>
-                  <a:srgbClr val="222A35"/>
-                </a:solidFill>
-              </a:rPr>
-              <a:t>  的最优结果</a:t>
-            </a:r>
-          </a:p>
-          <a:p>
-            <a:pPr algn="l"/>
-            <a:r>
-              <a:rPr sz="1300" b="0">
-                <a:solidFill>
-                  <a:srgbClr val="222A35"/>
-                </a:solidFill>
-              </a:rPr>
-              <a:t/>
-            </a:r>
-          </a:p>
-          <a:p>
-            <a:pPr algn="l"/>
-            <a:r>
-              <a:rPr sz="1300" b="0">
-                <a:solidFill>
-                  <a:srgbClr val="222A35"/>
-                </a:solidFill>
-              </a:rPr>
-              <a:t>本次：10/10 检查全部通过</a:t>
-            </a:r>
-          </a:p>
-          <a:p>
-            <a:pPr algn="l"/>
-            <a:r>
-              <a:rPr sz="1300" b="0">
-                <a:solidFill>
-                  <a:srgbClr val="222A35"/>
-                </a:solidFill>
-              </a:rPr>
-              <a:t>（284 s，含 88 项旧测试）</a:t>
-            </a:r>
-          </a:p>
-        </p:txBody>
-      </p:sp>
-    </p:spTree>
-  </p:cSld>
-  <p:clrMapOvr>
-    <a:masterClrMapping/>
-  </p:clrMapOvr>
-</p:sld>
-</file>
-
-<file path=ppt/slides/slide12.xml><?xml version="1.0" encoding="utf-8"?>
-<p:sld xmlns:a="http://schemas.openxmlformats.org/drawingml/2006/main" xmlns:p="http://schemas.openxmlformats.org/presentationml/2006/main" xmlns:r="http://schemas.openxmlformats.org/officeDocument/2006/relationships">
-  <p:cSld>
-    <p:spTree>
-      <p:nvGrpSpPr>
-        <p:cNvPr id="1" name=""/>
-        <p:cNvGrpSpPr/>
-        <p:nvPr/>
-      </p:nvGrpSpPr>
-      <p:grpSpPr/>
-      <p:sp>
-        <p:nvSpPr>
-          <p:cNvPr id="2" name="Rectangle 1"/>
-          <p:cNvSpPr/>
-          <p:nvPr/>
-        </p:nvSpPr>
-        <p:spPr>
-          <a:xfrm>
-            <a:off x="0" y="0"/>
-            <a:ext cx="12191695" cy="868680"/>
-          </a:xfrm>
-          <a:prstGeom prst="rect">
-            <a:avLst/>
-          </a:prstGeom>
-          <a:solidFill>
-            <a:srgbClr val="1F77B4"/>
-          </a:solidFill>
-          <a:ln>
-            <a:noFill/>
-          </a:ln>
-        </p:spPr>
-        <p:style>
-          <a:lnRef idx="1">
-            <a:schemeClr val="accent1"/>
-          </a:lnRef>
-          <a:fillRef idx="3">
-            <a:schemeClr val="accent1"/>
-          </a:fillRef>
-          <a:effectRef idx="2">
-            <a:schemeClr val="accent1"/>
-          </a:effectRef>
-          <a:fontRef idx="minor">
-            <a:schemeClr val="lt1"/>
-          </a:fontRef>
-        </p:style>
-        <p:txBody>
-          <a:bodyPr rtlCol="0" anchor="ctr"/>
-          <a:lstStyle/>
-          <a:p>
-            <a:pPr algn="ctr"/>
-          </a:p>
-        </p:txBody>
-      </p:sp>
-      <p:sp>
-        <p:nvSpPr>
-          <p:cNvPr id="3" name="TextBox 2"/>
-          <p:cNvSpPr txBox="1"/>
-          <p:nvPr/>
-        </p:nvSpPr>
-        <p:spPr>
-          <a:xfrm>
-            <a:off x="457200" y="109728"/>
-            <a:ext cx="11338560" cy="548640"/>
-          </a:xfrm>
-          <a:prstGeom prst="rect">
-            <a:avLst/>
-          </a:prstGeom>
-          <a:noFill/>
-        </p:spPr>
-        <p:txBody>
-          <a:bodyPr wrap="square">
-            <a:spAutoFit/>
-          </a:bodyPr>
-          <a:lstStyle/>
-          <a:p>
-            <a:pPr algn="l"/>
-            <a:r>
-              <a:rPr sz="2600" b="1">
-                <a:solidFill>
-                  <a:srgbClr val="FFFFFF"/>
-                </a:solidFill>
-              </a:rPr>
-              <a:t>测试与代码质量</a:t>
-            </a:r>
-          </a:p>
-        </p:txBody>
-      </p:sp>
-      <p:sp>
-        <p:nvSpPr>
-          <p:cNvPr id="4" name="TextBox 3"/>
-          <p:cNvSpPr txBox="1"/>
-          <p:nvPr/>
-        </p:nvSpPr>
-        <p:spPr>
-          <a:xfrm>
-            <a:off x="502920" y="566928"/>
-            <a:ext cx="11247120" cy="320040"/>
-          </a:xfrm>
-          <a:prstGeom prst="rect">
-            <a:avLst/>
-          </a:prstGeom>
-          <a:noFill/>
-        </p:spPr>
-        <p:txBody>
-          <a:bodyPr wrap="square">
-            <a:spAutoFit/>
-          </a:bodyPr>
-          <a:lstStyle/>
-          <a:p>
-            <a:pPr algn="l"/>
-            <a:r>
-              <a:rPr sz="1300" b="0">
-                <a:solidFill>
-                  <a:srgbClr val="DDE8F5"/>
-                </a:solidFill>
-              </a:rPr>
-              <a:t>88 项测试全部通过</a:t>
-            </a:r>
-          </a:p>
-        </p:txBody>
-      </p:sp>
-      <p:sp>
-        <p:nvSpPr>
-          <p:cNvPr id="5" name="TextBox 4"/>
-          <p:cNvSpPr txBox="1"/>
-          <p:nvPr/>
-        </p:nvSpPr>
-        <p:spPr>
-          <a:xfrm>
-            <a:off x="640080" y="1188720"/>
-            <a:ext cx="6675120" cy="4937760"/>
-          </a:xfrm>
-          <a:prstGeom prst="rect">
-            <a:avLst/>
-          </a:prstGeom>
-          <a:noFill/>
-        </p:spPr>
-        <p:txBody>
-          <a:bodyPr wrap="square">
-            <a:spAutoFit/>
-          </a:bodyPr>
-          <a:lstStyle/>
-          <a:p>
-            <a:pPr>
-              <a:spcAft>
-                <a:spcPts val="600"/>
-              </a:spcAft>
-            </a:pPr>
-            <a:r>
-              <a:rPr sz="1400" b="1">
-                <a:solidFill>
-                  <a:srgbClr val="222A35"/>
-                </a:solidFill>
-              </a:rPr>
-              <a:t>• 波形</a:t>
-            </a:r>
-            <a:r>
-              <a:rPr sz="1300">
-                <a:solidFill>
-                  <a:srgbClr val="666666"/>
-                </a:solidFill>
-              </a:rPr>
-              <a:t>　端点严格正确、单调有界、非法参数/奇异端点拒绝、解析导数 vs 有限差分</a:t>
-            </a:r>
-          </a:p>
-          <a:p>
-            <a:pPr>
-              <a:spcAft>
-                <a:spcPts val="600"/>
-              </a:spcAft>
-            </a:pPr>
-            <a:r>
-              <a:rPr sz="1400" b="1">
-                <a:solidFill>
-                  <a:srgbClr val="222A35"/>
-                </a:solidFill>
-              </a:rPr>
-              <a:t>• 复现</a:t>
-            </a:r>
-            <a:r>
-              <a:rPr sz="1300">
-                <a:solidFill>
-                  <a:srgbClr val="666666"/>
-                </a:solidFill>
-              </a:rPr>
-              <a:t>　sequential_600us 与 Level 1 轨迹逐点一致；时变积分器静态极限与 Level 0 一致</a:t>
-            </a:r>
-          </a:p>
-          <a:p>
-            <a:pPr>
-              <a:spcAft>
-                <a:spcPts val="600"/>
-              </a:spcAft>
-            </a:pPr>
-            <a:r>
-              <a:rPr sz="1400" b="1">
-                <a:solidFill>
-                  <a:srgbClr val="222A35"/>
-                </a:solidFill>
-              </a:rPr>
-              <a:t>• 防泄漏</a:t>
-            </a:r>
-            <a:r>
-              <a:rPr sz="1300">
-                <a:solidFill>
-                  <a:srgbClr val="666666"/>
-                </a:solidFill>
-              </a:rPr>
-              <a:t>　三池种子互不相同；spy 测试验证优化全程只抽取 optimization/selection 池</a:t>
-            </a:r>
-          </a:p>
-          <a:p>
-            <a:pPr>
-              <a:spcAft>
-                <a:spcPts val="600"/>
-              </a:spcAft>
-            </a:pPr>
-            <a:r>
-              <a:rPr sz="1400" b="1">
-                <a:solidFill>
-                  <a:srgbClr val="222A35"/>
-                </a:solidFill>
-              </a:rPr>
-              <a:t>• 公平性</a:t>
-            </a:r>
-            <a:r>
-              <a:rPr sz="1300">
-                <a:solidFill>
-                  <a:srgbClr val="666666"/>
-                </a:solidFill>
-              </a:rPr>
-              <a:t>　CRN：三波形初态逐行完全相同；near-threshold 样本保留并按严格符号计数</a:t>
-            </a:r>
-          </a:p>
-          <a:p>
-            <a:pPr>
-              <a:spcAft>
-                <a:spcPts val="600"/>
-              </a:spcAft>
-            </a:pPr>
-            <a:r>
-              <a:rPr sz="1400" b="1">
-                <a:solidFill>
-                  <a:srgbClr val="222A35"/>
-                </a:solidFill>
-              </a:rPr>
-              <a:t>• 统计</a:t>
-            </a:r>
-            <a:r>
-              <a:rPr sz="1300">
-                <a:solidFill>
-                  <a:srgbClr val="666666"/>
-                </a:solidFill>
-              </a:rPr>
-              <a:t>　Wilson 区间、配对 bootstrap 在构造数据上验证正确</a:t>
-            </a:r>
-          </a:p>
-          <a:p>
-            <a:pPr>
-              <a:spcAft>
-                <a:spcPts val="600"/>
-              </a:spcAft>
-            </a:pPr>
-            <a:r>
-              <a:rPr sz="1400" b="1">
-                <a:solidFill>
-                  <a:srgbClr val="222A35"/>
-                </a:solidFill>
-              </a:rPr>
-              <a:t>• 工程</a:t>
-            </a:r>
-            <a:r>
-              <a:rPr sz="1300">
-                <a:solidFill>
-                  <a:srgbClr val="666666"/>
-                </a:solidFill>
-              </a:rPr>
-              <a:t>　CLI 各 stage 冒烟测试、检查点断点续跑、CSV/JSON schema 与图片程序化检查</a:t>
-            </a:r>
-          </a:p>
-        </p:txBody>
-      </p:sp>
-      <p:sp>
-        <p:nvSpPr>
-          <p:cNvPr id="6" name="Rectangle 5"/>
-          <p:cNvSpPr/>
-          <p:nvPr/>
-        </p:nvSpPr>
-        <p:spPr>
-          <a:xfrm>
-            <a:off x="7589520" y="1188720"/>
-            <a:ext cx="4114800" cy="4754880"/>
-          </a:xfrm>
-          <a:prstGeom prst="rect">
-            <a:avLst/>
-          </a:prstGeom>
-          <a:solidFill>
-            <a:srgbClr val="F2F2F2"/>
-          </a:solidFill>
-        </p:spPr>
-        <p:style>
-          <a:lnRef idx="1">
-            <a:schemeClr val="accent1"/>
-          </a:lnRef>
-          <a:fillRef idx="3">
-            <a:schemeClr val="accent1"/>
-          </a:fillRef>
-          <a:effectRef idx="2">
-            <a:schemeClr val="accent1"/>
-          </a:effectRef>
-          <a:fontRef idx="minor">
-            <a:schemeClr val="lt1"/>
-          </a:fontRef>
-        </p:style>
-        <p:txBody>
-          <a:bodyPr rtlCol="0" anchor="ctr"/>
-          <a:lstStyle/>
-          <a:p>
-            <a:pPr algn="ctr"/>
-          </a:p>
-        </p:txBody>
-      </p:sp>
-      <p:sp>
-        <p:nvSpPr>
-          <p:cNvPr id="7" name="TextBox 6"/>
-          <p:cNvSpPr txBox="1"/>
-          <p:nvPr/>
-        </p:nvSpPr>
-        <p:spPr>
-          <a:xfrm>
-            <a:off x="7818120" y="1371600"/>
-            <a:ext cx="3657600" cy="4389120"/>
-          </a:xfrm>
-          <a:prstGeom prst="rect">
-            <a:avLst/>
-          </a:prstGeom>
-          <a:noFill/>
-        </p:spPr>
-        <p:txBody>
-          <a:bodyPr wrap="square">
-            <a:spAutoFit/>
-          </a:bodyPr>
-          <a:lstStyle/>
-          <a:p>
-            <a:pPr algn="l"/>
-            <a:r>
-              <a:rPr sz="1200" b="0">
-                <a:solidFill>
-                  <a:srgbClr val="222A35"/>
-                </a:solidFill>
-              </a:rPr>
-              <a:t>复现命令</a:t>
-            </a:r>
-          </a:p>
-          <a:p>
-            <a:pPr algn="l"/>
-            <a:r>
-              <a:rPr sz="1200" b="0">
-                <a:solidFill>
-                  <a:srgbClr val="222A35"/>
-                </a:solidFill>
-              </a:rPr>
-              <a:t/>
-            </a:r>
-          </a:p>
-          <a:p>
-            <a:pPr algn="l"/>
-            <a:r>
-              <a:rPr sz="1200" b="0">
-                <a:solidFill>
-                  <a:srgbClr val="222A35"/>
-                </a:solidFill>
-              </a:rPr>
-              <a:t>$ pip install -e ".[dev]"</a:t>
-            </a:r>
-          </a:p>
-          <a:p>
-            <a:pPr algn="l"/>
-            <a:r>
-              <a:rPr sz="1200" b="0">
-                <a:solidFill>
-                  <a:srgbClr val="222A35"/>
-                </a:solidFill>
-              </a:rPr>
-              <a:t>$ pytest -q</a:t>
-            </a:r>
-          </a:p>
-          <a:p>
-            <a:pPr algn="l"/>
-            <a:r>
-              <a:rPr sz="1200" b="0">
-                <a:solidFill>
-                  <a:srgbClr val="222A35"/>
-                </a:solidFill>
-              </a:rPr>
-              <a:t>→ 88 passed</a:t>
-            </a:r>
-          </a:p>
-          <a:p>
-            <a:pPr algn="l"/>
-            <a:r>
-              <a:rPr sz="1200" b="0">
-                <a:solidFill>
-                  <a:srgbClr val="222A35"/>
-                </a:solidFill>
-              </a:rPr>
-              <a:t/>
-            </a:r>
-          </a:p>
-          <a:p>
-            <a:pPr algn="l"/>
-            <a:r>
-              <a:rPr sz="1200" b="0">
-                <a:solidFill>
-                  <a:srgbClr val="222A35"/>
-                </a:solidFill>
-              </a:rPr>
-              <a:t>$ level2-joint-transfer \</a:t>
-            </a:r>
-          </a:p>
-          <a:p>
-            <a:pPr algn="l"/>
-            <a:r>
-              <a:rPr sz="1200" b="0">
-                <a:solidFill>
-                  <a:srgbClr val="222A35"/>
-                </a:solidFill>
-              </a:rPr>
-              <a:t>    --config configs/…yaml \</a:t>
-            </a:r>
-          </a:p>
-          <a:p>
-            <a:pPr algn="l"/>
-            <a:r>
-              <a:rPr sz="1200" b="0">
-                <a:solidFill>
-                  <a:srgbClr val="222A35"/>
-                </a:solidFill>
-              </a:rPr>
-              <a:t>    --stage all</a:t>
-            </a:r>
-          </a:p>
-          <a:p>
-            <a:pPr algn="l"/>
-            <a:r>
-              <a:rPr sz="1200" b="0">
-                <a:solidFill>
-                  <a:srgbClr val="222A35"/>
-                </a:solidFill>
-              </a:rPr>
-              <a:t/>
-            </a:r>
-          </a:p>
-          <a:p>
-            <a:pPr algn="l"/>
-            <a:r>
-              <a:rPr sz="1200" b="0">
-                <a:solidFill>
-                  <a:srgbClr val="222A35"/>
-                </a:solidFill>
-              </a:rPr>
-              <a:t>阶段：preflight / optimize /</a:t>
-            </a:r>
-          </a:p>
-          <a:p>
-            <a:pPr algn="l"/>
-            <a:r>
-              <a:rPr sz="1200" b="0">
-                <a:solidFill>
-                  <a:srgbClr val="222A35"/>
-                </a:solidFill>
-              </a:rPr>
-              <a:t>validate / robustness / all</a:t>
-            </a:r>
-          </a:p>
-        </p:txBody>
-      </p:sp>
-    </p:spTree>
-  </p:cSld>
-  <p:clrMapOvr>
-    <a:masterClrMapping/>
-  </p:clrMapOvr>
-</p:sld>
-</file>
-
-<file path=ppt/slides/slide13.xml><?xml version="1.0" encoding="utf-8"?>
-<p:sld xmlns:a="http://schemas.openxmlformats.org/drawingml/2006/main" xmlns:p="http://schemas.openxmlformats.org/presentationml/2006/main" xmlns:r="http://schemas.openxmlformats.org/officeDocument/2006/relationships">
-  <p:cSld>
-    <p:spTree>
-      <p:nvGrpSpPr>
-        <p:cNvPr id="1" name=""/>
-        <p:cNvGrpSpPr/>
-        <p:nvPr/>
-      </p:nvGrpSpPr>
-      <p:grpSpPr/>
-      <p:sp>
-        <p:nvSpPr>
-          <p:cNvPr id="2" name="Rectangle 1"/>
-          <p:cNvSpPr/>
-          <p:nvPr/>
-        </p:nvSpPr>
-        <p:spPr>
-          <a:xfrm>
-            <a:off x="0" y="0"/>
-            <a:ext cx="12191695" cy="868680"/>
-          </a:xfrm>
-          <a:prstGeom prst="rect">
-            <a:avLst/>
-          </a:prstGeom>
-          <a:solidFill>
-            <a:srgbClr val="1F77B4"/>
-          </a:solidFill>
-          <a:ln>
-            <a:noFill/>
-          </a:ln>
-        </p:spPr>
-        <p:style>
-          <a:lnRef idx="1">
-            <a:schemeClr val="accent1"/>
-          </a:lnRef>
-          <a:fillRef idx="3">
-            <a:schemeClr val="accent1"/>
-          </a:fillRef>
-          <a:effectRef idx="2">
-            <a:schemeClr val="accent1"/>
-          </a:effectRef>
-          <a:fontRef idx="minor">
-            <a:schemeClr val="lt1"/>
-          </a:fontRef>
-        </p:style>
-        <p:txBody>
-          <a:bodyPr rtlCol="0" anchor="ctr"/>
-          <a:lstStyle/>
-          <a:p>
-            <a:pPr algn="ctr"/>
-          </a:p>
-        </p:txBody>
-      </p:sp>
-      <p:sp>
-        <p:nvSpPr>
-          <p:cNvPr id="3" name="TextBox 2"/>
-          <p:cNvSpPr txBox="1"/>
-          <p:nvPr/>
-        </p:nvSpPr>
-        <p:spPr>
-          <a:xfrm>
-            <a:off x="457200" y="109728"/>
-            <a:ext cx="11338560" cy="548640"/>
-          </a:xfrm>
-          <a:prstGeom prst="rect">
-            <a:avLst/>
-          </a:prstGeom>
-          <a:noFill/>
-        </p:spPr>
-        <p:txBody>
-          <a:bodyPr wrap="square">
-            <a:spAutoFit/>
-          </a:bodyPr>
-          <a:lstStyle/>
-          <a:p>
-            <a:pPr algn="l"/>
-            <a:r>
-              <a:rPr sz="2600" b="1">
-                <a:solidFill>
-                  <a:srgbClr val="FFFFFF"/>
-                </a:solidFill>
-              </a:rPr>
-              <a:t>功-能核算：转移期间外部做功的显式验证</a:t>
-            </a:r>
-          </a:p>
-        </p:txBody>
-      </p:sp>
-      <p:sp>
-        <p:nvSpPr>
-          <p:cNvPr id="4" name="TextBox 3"/>
-          <p:cNvSpPr txBox="1"/>
-          <p:nvPr/>
-        </p:nvSpPr>
-        <p:spPr>
-          <a:xfrm>
-            <a:off x="502920" y="566928"/>
-            <a:ext cx="11247120" cy="320040"/>
-          </a:xfrm>
-          <a:prstGeom prst="rect">
-            <a:avLst/>
-          </a:prstGeom>
-          <a:noFill/>
-        </p:spPr>
-        <p:txBody>
-          <a:bodyPr wrap="square">
-            <a:spAutoFit/>
-          </a:bodyPr>
-          <a:lstStyle/>
-          <a:p>
-            <a:pPr algn="l"/>
-            <a:r>
-              <a:rPr sz="1300" b="0">
-                <a:solidFill>
-                  <a:srgbClr val="DDE8F5"/>
-                </a:solidFill>
-              </a:rPr>
-              <a:t>demo 输出 · 多条代表轨迹</a:t>
-            </a:r>
-          </a:p>
-        </p:txBody>
-      </p:sp>
-      <p:pic>
-        <p:nvPicPr>
-          <p:cNvPr id="5" name="Picture 4" descr="work_energy_balance.png"/>
-          <p:cNvPicPr>
-            <a:picLocks noChangeAspect="1"/>
-          </p:cNvPicPr>
-          <p:nvPr/>
-        </p:nvPicPr>
-        <p:blipFill>
-          <a:blip r:embed="rId2"/>
-          <a:stretch>
-            <a:fillRect/>
-          </a:stretch>
-        </p:blipFill>
-        <p:spPr>
-          <a:xfrm>
-            <a:off x="1970042" y="914400"/>
-            <a:ext cx="8221435" cy="4846320"/>
-          </a:xfrm>
-          <a:prstGeom prst="rect">
-            <a:avLst/>
-          </a:prstGeom>
-        </p:spPr>
-      </p:pic>
-      <p:sp>
-        <p:nvSpPr>
-          <p:cNvPr id="6" name="TextBox 5"/>
-          <p:cNvSpPr txBox="1"/>
-          <p:nvPr/>
-        </p:nvSpPr>
-        <p:spPr>
-          <a:xfrm>
-            <a:off x="640080" y="5897880"/>
-            <a:ext cx="10972800" cy="731520"/>
-          </a:xfrm>
-          <a:prstGeom prst="rect">
-            <a:avLst/>
-          </a:prstGeom>
-          <a:noFill/>
-        </p:spPr>
-        <p:txBody>
-          <a:bodyPr wrap="square">
-            <a:spAutoFit/>
-          </a:bodyPr>
-          <a:lstStyle/>
-          <a:p>
-            <a:pPr algn="l"/>
-            <a:r>
-              <a:rPr sz="1300" b="0">
-                <a:solidFill>
-                  <a:srgbClr val="666666"/>
-                </a:solidFill>
-              </a:rPr>
-              <a:t>黑线 ΔE(t) 与绿线外部总功 W_ext(t) 逐点重合，残差 R_W（红线）远小于 1e-3·D_SLM；深度功在降深段把能量取走，移动功在移动段注入能量，两者符号与量级符合物理直觉。</a:t>
-            </a:r>
-          </a:p>
-        </p:txBody>
-      </p:sp>
-    </p:spTree>
-  </p:cSld>
-  <p:clrMapOvr>
-    <a:masterClrMapping/>
-  </p:clrMapOvr>
-</p:sld>
-</file>
-
-<file path=ppt/slides/slide14.xml><?xml version="1.0" encoding="utf-8"?>
-<p:sld xmlns:a="http://schemas.openxmlformats.org/drawingml/2006/main" xmlns:p="http://schemas.openxmlformats.org/presentationml/2006/main" xmlns:r="http://schemas.openxmlformats.org/officeDocument/2006/relationships">
-  <p:cSld>
-    <p:spTree>
-      <p:nvGrpSpPr>
-        <p:cNvPr id="1" name=""/>
-        <p:cNvGrpSpPr/>
-        <p:nvPr/>
-      </p:nvGrpSpPr>
-      <p:grpSpPr/>
-      <p:sp>
-        <p:nvSpPr>
-          <p:cNvPr id="2" name="Rectangle 1"/>
-          <p:cNvSpPr/>
-          <p:nvPr/>
-        </p:nvSpPr>
-        <p:spPr>
-          <a:xfrm>
-            <a:off x="0" y="0"/>
-            <a:ext cx="12191695" cy="868680"/>
-          </a:xfrm>
-          <a:prstGeom prst="rect">
-            <a:avLst/>
-          </a:prstGeom>
-          <a:solidFill>
-            <a:srgbClr val="1F77B4"/>
-          </a:solidFill>
-          <a:ln>
-            <a:noFill/>
-          </a:ln>
-        </p:spPr>
-        <p:style>
-          <a:lnRef idx="1">
-            <a:schemeClr val="accent1"/>
-          </a:lnRef>
-          <a:fillRef idx="3">
-            <a:schemeClr val="accent1"/>
-          </a:fillRef>
-          <a:effectRef idx="2">
-            <a:schemeClr val="accent1"/>
-          </a:effectRef>
-          <a:fontRef idx="minor">
-            <a:schemeClr val="lt1"/>
-          </a:fontRef>
-        </p:style>
-        <p:txBody>
-          <a:bodyPr rtlCol="0" anchor="ctr"/>
-          <a:lstStyle/>
-          <a:p>
-            <a:pPr algn="ctr"/>
-          </a:p>
-        </p:txBody>
-      </p:sp>
-      <p:sp>
-        <p:nvSpPr>
-          <p:cNvPr id="3" name="TextBox 2"/>
-          <p:cNvSpPr txBox="1"/>
-          <p:nvPr/>
-        </p:nvSpPr>
-        <p:spPr>
-          <a:xfrm>
-            <a:off x="457200" y="109728"/>
-            <a:ext cx="11338560" cy="548640"/>
-          </a:xfrm>
-          <a:prstGeom prst="rect">
-            <a:avLst/>
-          </a:prstGeom>
-          <a:noFill/>
-        </p:spPr>
-        <p:txBody>
-          <a:bodyPr wrap="square">
-            <a:spAutoFit/>
-          </a:bodyPr>
-          <a:lstStyle/>
-          <a:p>
-            <a:pPr algn="l"/>
-            <a:r>
-              <a:rPr sz="2600" b="1">
-                <a:solidFill>
-                  <a:srgbClr val="FFFFFF"/>
-                </a:solidFill>
-              </a:rPr>
-              <a:t>步长收敛与俘获标签稳定性</a:t>
-            </a:r>
-          </a:p>
-        </p:txBody>
-      </p:sp>
-      <p:sp>
-        <p:nvSpPr>
-          <p:cNvPr id="4" name="TextBox 3"/>
-          <p:cNvSpPr txBox="1"/>
-          <p:nvPr/>
-        </p:nvSpPr>
-        <p:spPr>
-          <a:xfrm>
-            <a:off x="502920" y="566928"/>
-            <a:ext cx="11247120" cy="320040"/>
-          </a:xfrm>
-          <a:prstGeom prst="rect">
-            <a:avLst/>
-          </a:prstGeom>
-          <a:noFill/>
-        </p:spPr>
-        <p:txBody>
-          <a:bodyPr wrap="square">
-            <a:spAutoFit/>
-          </a:bodyPr>
-          <a:lstStyle/>
-          <a:p>
-            <a:pPr algn="l"/>
-            <a:r>
-              <a:rPr sz="1300" b="0">
-                <a:solidFill>
-                  <a:srgbClr val="DDE8F5"/>
-                </a:solidFill>
-              </a:rPr>
-              <a:t>demo 输出 · dt = 0.10 / 0.05 / 0.025 μs</a:t>
-            </a:r>
-          </a:p>
-        </p:txBody>
-      </p:sp>
-      <p:pic>
-        <p:nvPicPr>
-          <p:cNvPr id="5" name="Picture 4" descr="timestep_convergence.png"/>
-          <p:cNvPicPr>
-            <a:picLocks noChangeAspect="1"/>
-          </p:cNvPicPr>
-          <p:nvPr/>
-        </p:nvPicPr>
-        <p:blipFill>
-          <a:blip r:embed="rId2"/>
-          <a:stretch>
-            <a:fillRect/>
-          </a:stretch>
-        </p:blipFill>
-        <p:spPr>
-          <a:xfrm>
-            <a:off x="228600" y="996695"/>
-            <a:ext cx="11704320" cy="4681728"/>
-          </a:xfrm>
-          <a:prstGeom prst="rect">
-            <a:avLst/>
-          </a:prstGeom>
-        </p:spPr>
-      </p:pic>
-      <p:sp>
-        <p:nvSpPr>
-          <p:cNvPr id="6" name="TextBox 5"/>
-          <p:cNvSpPr txBox="1"/>
-          <p:nvPr/>
-        </p:nvSpPr>
-        <p:spPr>
-          <a:xfrm>
-            <a:off x="640080" y="5897880"/>
-            <a:ext cx="10972800" cy="731520"/>
-          </a:xfrm>
-          <a:prstGeom prst="rect">
-            <a:avLst/>
-          </a:prstGeom>
-          <a:noFill/>
-        </p:spPr>
-        <p:txBody>
-          <a:bodyPr wrap="square">
-            <a:spAutoFit/>
-          </a:bodyPr>
-          <a:lstStyle/>
-          <a:p>
-            <a:pPr algn="l"/>
-            <a:r>
-              <a:rPr sz="1300" b="0">
-                <a:solidFill>
-                  <a:srgbClr val="666666"/>
-                </a:solidFill>
-              </a:rPr>
-              <a:t>左：末态能量最大偏差随 dt 减小呈二阶下降（对数坐标）；右：三种波形俘获标签翻转率 ≈ 0，说明 dt=0.05 μs 的验证结果不是积分误差的产物。</a:t>
-            </a:r>
-          </a:p>
-        </p:txBody>
-      </p:sp>
-    </p:spTree>
-  </p:cSld>
-  <p:clrMapOvr>
-    <a:masterClrMapping/>
-  </p:clrMapOvr>
-</p:sld>
-</file>
-
-<file path=ppt/slides/slide15.xml><?xml version="1.0" encoding="utf-8"?>
-<p:sld xmlns:a="http://schemas.openxmlformats.org/drawingml/2006/main" xmlns:p="http://schemas.openxmlformats.org/presentationml/2006/main" xmlns:r="http://schemas.openxmlformats.org/officeDocument/2006/relationships">
-  <p:cSld>
-    <p:spTree>
-      <p:nvGrpSpPr>
-        <p:cNvPr id="1" name=""/>
-        <p:cNvGrpSpPr/>
-        <p:nvPr/>
-      </p:nvGrpSpPr>
-      <p:grpSpPr/>
-      <p:sp>
-        <p:nvSpPr>
-          <p:cNvPr id="2" name="Rectangle 1"/>
-          <p:cNvSpPr/>
-          <p:nvPr/>
-        </p:nvSpPr>
-        <p:spPr>
-          <a:xfrm>
-            <a:off x="0" y="0"/>
-            <a:ext cx="12191695" cy="868680"/>
-          </a:xfrm>
-          <a:prstGeom prst="rect">
-            <a:avLst/>
-          </a:prstGeom>
-          <a:solidFill>
-            <a:srgbClr val="1F77B4"/>
-          </a:solidFill>
-          <a:ln>
-            <a:noFill/>
-          </a:ln>
-        </p:spPr>
-        <p:style>
-          <a:lnRef idx="1">
-            <a:schemeClr val="accent1"/>
-          </a:lnRef>
-          <a:fillRef idx="3">
-            <a:schemeClr val="accent1"/>
-          </a:fillRef>
-          <a:effectRef idx="2">
-            <a:schemeClr val="accent1"/>
-          </a:effectRef>
-          <a:fontRef idx="minor">
-            <a:schemeClr val="lt1"/>
-          </a:fontRef>
-        </p:style>
-        <p:txBody>
-          <a:bodyPr rtlCol="0" anchor="ctr"/>
-          <a:lstStyle/>
-          <a:p>
-            <a:pPr algn="ctr"/>
-          </a:p>
-        </p:txBody>
-      </p:sp>
-      <p:sp>
-        <p:nvSpPr>
-          <p:cNvPr id="3" name="TextBox 2"/>
-          <p:cNvSpPr txBox="1"/>
-          <p:nvPr/>
-        </p:nvSpPr>
-        <p:spPr>
-          <a:xfrm>
-            <a:off x="457200" y="109728"/>
-            <a:ext cx="11338560" cy="548640"/>
-          </a:xfrm>
-          <a:prstGeom prst="rect">
-            <a:avLst/>
-          </a:prstGeom>
-          <a:noFill/>
-        </p:spPr>
-        <p:txBody>
-          <a:bodyPr wrap="square">
-            <a:spAutoFit/>
-          </a:bodyPr>
-          <a:lstStyle/>
-          <a:p>
-            <a:pPr algn="l"/>
-            <a:r>
-              <a:rPr sz="2600" b="1">
-                <a:solidFill>
-                  <a:srgbClr val="FFFFFF"/>
-                </a:solidFill>
-              </a:rPr>
-              <a:t>结论</a:t>
-            </a:r>
-          </a:p>
-        </p:txBody>
-      </p:sp>
-      <p:sp>
-        <p:nvSpPr>
-          <p:cNvPr id="4" name="TextBox 3"/>
-          <p:cNvSpPr txBox="1"/>
-          <p:nvPr/>
-        </p:nvSpPr>
-        <p:spPr>
-          <a:xfrm>
-            <a:off x="502920" y="566928"/>
-            <a:ext cx="11247120" cy="320040"/>
-          </a:xfrm>
-          <a:prstGeom prst="rect">
-            <a:avLst/>
-          </a:prstGeom>
-          <a:noFill/>
-        </p:spPr>
-        <p:txBody>
-          <a:bodyPr wrap="square">
-            <a:spAutoFit/>
-          </a:bodyPr>
-          <a:lstStyle/>
-          <a:p>
-            <a:pPr algn="l"/>
-            <a:r>
-              <a:rPr sz="1300" b="0">
-                <a:solidFill>
-                  <a:srgbClr val="DDE8F5"/>
-                </a:solidFill>
-              </a:rPr>
-              <a:t>诚实报告是本 Level 的核心要求</a:t>
-            </a:r>
-          </a:p>
-        </p:txBody>
-      </p:sp>
-      <p:sp>
-        <p:nvSpPr>
-          <p:cNvPr id="5" name="TextBox 4"/>
-          <p:cNvSpPr txBox="1"/>
-          <p:nvPr/>
-        </p:nvSpPr>
-        <p:spPr>
-          <a:xfrm>
-            <a:off x="640080" y="1234440"/>
-            <a:ext cx="10881360" cy="3291840"/>
-          </a:xfrm>
-          <a:prstGeom prst="rect">
-            <a:avLst/>
-          </a:prstGeom>
-          <a:noFill/>
-        </p:spPr>
-        <p:txBody>
-          <a:bodyPr wrap="square">
-            <a:spAutoFit/>
-          </a:bodyPr>
-          <a:lstStyle/>
-          <a:p>
-            <a:pPr>
-              <a:spcAft>
-                <a:spcPts val="600"/>
-              </a:spcAft>
-            </a:pPr>
-            <a:r>
-              <a:rPr sz="1700" b="1">
-                <a:solidFill>
-                  <a:srgbClr val="222A35"/>
-                </a:solidFill>
-              </a:rPr>
-              <a:t>• 实现完成</a:t>
-            </a:r>
-            <a:r>
-              <a:rPr sz="1600">
-                <a:solidFill>
-                  <a:srgbClr val="666666"/>
-                </a:solidFill>
-              </a:rPr>
-              <a:t>　三类波形、功-能核算、分阶段优化、独立验证、鲁棒性检查全部实现并实际运行。</a:t>
-            </a:r>
-          </a:p>
-          <a:p>
-            <a:pPr>
-              <a:spcAft>
-                <a:spcPts val="600"/>
-              </a:spcAft>
-            </a:pPr>
-            <a:r>
-              <a:rPr sz="1700" b="1">
-                <a:solidFill>
-                  <a:srgbClr val="222A35"/>
-                </a:solidFill>
-              </a:rPr>
-              <a:t>• 物理结论</a:t>
-            </a:r>
-            <a:r>
-              <a:rPr sz="1600">
-                <a:solidFill>
-                  <a:srgbClr val="666666"/>
-                </a:solidFill>
-              </a:rPr>
-              <a:t>　5 μK 工况下问题处于饱和区：三波形俘获率均 100%，配对差为 0 —— 未观察到统计上明确的提升，如实报告，不得据此调参。</a:t>
-            </a:r>
-          </a:p>
-          <a:p>
-            <a:pPr>
-              <a:spcAft>
-                <a:spcPts val="600"/>
-              </a:spcAft>
-            </a:pPr>
-            <a:r>
-              <a:rPr sz="1700" b="1">
-                <a:solidFill>
-                  <a:srgbClr val="222A35"/>
-                </a:solidFill>
-              </a:rPr>
-              <a:t>• 数值可信</a:t>
-            </a:r>
-            <a:r>
-              <a:rPr sz="1600">
-                <a:solidFill>
-                  <a:srgbClr val="666666"/>
-                </a:solidFill>
-              </a:rPr>
-              <a:t>　preflight 10/10 通过；功-能残差、保持段误差、步长收敛均远优于验收阈值。</a:t>
-            </a:r>
-          </a:p>
-          <a:p>
-            <a:pPr>
-              <a:spcAft>
-                <a:spcPts val="600"/>
-              </a:spcAft>
-            </a:pPr>
-            <a:r>
-              <a:rPr sz="1700" b="1">
-                <a:solidFill>
-                  <a:srgbClr val="222A35"/>
-                </a:solidFill>
-              </a:rPr>
-              <a:t>• 鉴别力限制</a:t>
-            </a:r>
-            <a:r>
-              <a:rPr sz="1600">
-                <a:solidFill>
-                  <a:srgbClr val="666666"/>
-                </a:solidFill>
-              </a:rPr>
-              <a:t>　如需区分波形优劣，应升温或进一步压缩时长，把系统推离 100% 饱和区。</a:t>
-            </a:r>
-          </a:p>
-        </p:txBody>
-      </p:sp>
-      <p:sp>
-        <p:nvSpPr>
-          <p:cNvPr id="6" name="Rectangle 5"/>
-          <p:cNvSpPr/>
-          <p:nvPr/>
-        </p:nvSpPr>
-        <p:spPr>
-          <a:xfrm>
-            <a:off x="640080" y="4937760"/>
-            <a:ext cx="10881360" cy="1463040"/>
-          </a:xfrm>
-          <a:prstGeom prst="rect">
-            <a:avLst/>
-          </a:prstGeom>
-          <a:solidFill>
-            <a:srgbClr val="E8F0FE"/>
-          </a:solidFill>
-          <a:ln>
-            <a:solidFill>
-              <a:srgbClr val="1F77B4"/>
-            </a:solidFill>
-          </a:ln>
-        </p:spPr>
-        <p:style>
-          <a:lnRef idx="1">
-            <a:schemeClr val="accent1"/>
-          </a:lnRef>
-          <a:fillRef idx="3">
-            <a:schemeClr val="accent1"/>
-          </a:fillRef>
-          <a:effectRef idx="2">
-            <a:schemeClr val="accent1"/>
-          </a:effectRef>
-          <a:fontRef idx="minor">
-            <a:schemeClr val="lt1"/>
-          </a:fontRef>
-        </p:style>
-        <p:txBody>
-          <a:bodyPr rtlCol="0" anchor="ctr"/>
-          <a:lstStyle/>
-          <a:p>
-            <a:pPr algn="ctr"/>
-          </a:p>
-        </p:txBody>
-      </p:sp>
-      <p:sp>
-        <p:nvSpPr>
-          <p:cNvPr id="7" name="TextBox 6"/>
-          <p:cNvSpPr txBox="1"/>
-          <p:nvPr/>
-        </p:nvSpPr>
-        <p:spPr>
-          <a:xfrm>
-            <a:off x="914400" y="5120640"/>
-            <a:ext cx="10332720" cy="1097280"/>
-          </a:xfrm>
-          <a:prstGeom prst="rect">
-            <a:avLst/>
-          </a:prstGeom>
-          <a:noFill/>
-        </p:spPr>
-        <p:txBody>
-          <a:bodyPr wrap="square">
-            <a:spAutoFit/>
-          </a:bodyPr>
-          <a:lstStyle/>
-          <a:p>
-            <a:pPr algn="l"/>
-            <a:r>
-              <a:rPr sz="1400" b="0">
-                <a:solidFill>
-                  <a:srgbClr val="222A35"/>
-                </a:solidFill>
-              </a:rPr>
-              <a:t>留给后续 Level 的物理过程：二维/轴向运动、AOD 柱面透镜效应、光子散射、技术噪声、量子内态与相干性、加热/损失随机过程、多原子相互作用、反向 pick-up 与 610 μm 长距离运输。</a:t>
+              <a:t>AOD 起动→停止时长与位移完全相同（44/39/35 μs × 2.4 μm，噪声 ×1）：快加速梯形（v_peak=1.18·v_avg）0.99/0.96/0.78 全面最优，三角（2.0×）0.48/0.09/0.00 最差——俘获由瞬时峰值速度决定，加速平缓与否是次要因素。</a:t>
             </a:r>
           </a:p>
         </p:txBody>
@@ -5017,7 +3794,7 @@
         <p:spPr>
           <a:xfrm>
             <a:off x="0" y="0"/>
-            <a:ext cx="12191695" cy="868680"/>
+            <a:ext cx="12191695" cy="786384"/>
           </a:xfrm>
           <a:prstGeom prst="rect">
             <a:avLst/>
@@ -5059,8 +3836,8 @@
         </p:nvSpPr>
         <p:spPr>
           <a:xfrm>
-            <a:off x="457200" y="109728"/>
-            <a:ext cx="11338560" cy="548640"/>
+            <a:off x="457200" y="91440"/>
+            <a:ext cx="11338560" cy="603504"/>
           </a:xfrm>
           <a:prstGeom prst="rect">
             <a:avLst/>
@@ -5073,28 +3850,51 @@
           </a:bodyPr>
           <a:lstStyle/>
           <a:p>
-            <a:pPr algn="l"/>
-            <a:r>
-              <a:rPr sz="2600" b="1">
+            <a:r>
+              <a:rPr sz="2500" b="1">
                 <a:solidFill>
                   <a:srgbClr val="FFFFFF"/>
                 </a:solidFill>
               </a:rPr>
-              <a:t>要回答的问题</a:t>
-            </a:r>
-          </a:p>
-        </p:txBody>
-      </p:sp>
-      <p:sp>
-        <p:nvSpPr>
-          <p:cNvPr id="4" name="TextBox 3"/>
+              <a:t>问题：600 μs 能压到 400 μs 吗？</a:t>
+            </a:r>
+          </a:p>
+        </p:txBody>
+      </p:sp>
+      <p:pic>
+        <p:nvPicPr>
+          <p:cNvPr id="4" name="Picture 3" descr="s01_问题.png"/>
+          <p:cNvPicPr>
+            <a:picLocks noChangeAspect="1"/>
+          </p:cNvPicPr>
+          <p:nvPr/>
+        </p:nvPicPr>
+        <p:blipFill>
+          <a:blip r:embed="rId2"/>
+          <a:stretch>
+            <a:fillRect/>
+          </a:stretch>
+        </p:blipFill>
+        <p:spPr>
+          <a:xfrm>
+            <a:off x="274319" y="990785"/>
+            <a:ext cx="11640312" cy="4739269"/>
+          </a:xfrm>
+          <a:prstGeom prst="rect">
+            <a:avLst/>
+          </a:prstGeom>
+        </p:spPr>
+      </p:pic>
+      <p:sp>
+        <p:nvSpPr>
+          <p:cNvPr id="5" name="TextBox 4"/>
           <p:cNvSpPr txBox="1"/>
           <p:nvPr/>
         </p:nvSpPr>
         <p:spPr>
           <a:xfrm>
-            <a:off x="502920" y="566928"/>
-            <a:ext cx="11247120" cy="320040"/>
+            <a:off x="640080" y="5989320"/>
+            <a:ext cx="10881360" cy="548640"/>
           </a:xfrm>
           <a:prstGeom prst="rect">
             <a:avLst/>
@@ -5107,241 +3907,14 @@
           </a:bodyPr>
           <a:lstStyle/>
           <a:p>
-            <a:pPr algn="l"/>
-            <a:r>
-              <a:rPr sz="1300" b="0">
-                <a:solidFill>
-                  <a:srgbClr val="DDE8F5"/>
-                </a:solidFill>
-              </a:rPr>
-              <a:t>Level 2 的定位</a:t>
-            </a:r>
-          </a:p>
-        </p:txBody>
-      </p:sp>
-      <p:sp>
-        <p:nvSpPr>
-          <p:cNvPr id="5" name="TextBox 4"/>
-          <p:cNvSpPr txBox="1"/>
-          <p:nvPr/>
-        </p:nvSpPr>
-        <p:spPr>
-          <a:xfrm>
-            <a:off x="640080" y="1280160"/>
-            <a:ext cx="10881360" cy="3108960"/>
-          </a:xfrm>
-          <a:prstGeom prst="rect">
-            <a:avLst/>
-          </a:prstGeom>
-          <a:noFill/>
-        </p:spPr>
-        <p:txBody>
-          <a:bodyPr wrap="square">
-            <a:spAutoFit/>
-          </a:bodyPr>
-          <a:lstStyle/>
-          <a:p>
-            <a:pPr>
-              <a:spcAft>
-                <a:spcPts val="600"/>
-              </a:spcAft>
-            </a:pPr>
-            <a:r>
-              <a:rPr sz="1800" b="1">
-                <a:solidFill>
-                  <a:srgbClr val="222A35"/>
-                </a:solidFill>
-              </a:rPr>
-              <a:t>• 物理场景</a:t>
-            </a:r>
-            <a:r>
-              <a:rPr sz="1700">
+            <a:pPr algn="ctr"/>
+            <a:r>
+              <a:rPr sz="1400">
                 <a:solidFill>
                   <a:srgbClr val="666666"/>
                 </a:solidFill>
               </a:rPr>
-              <a:t>　280 μK AOD 光镊抓住一颗铯原子，旁边是静止的 140 μK SLM 光镊；AOD 一边挪向 SLM 一边关灯，把原子留给 SLM。</a:t>
-            </a:r>
-          </a:p>
-          <a:p>
-            <a:pPr>
-              <a:spcAft>
-                <a:spcPts val="600"/>
-              </a:spcAft>
-            </a:pPr>
-            <a:r>
-              <a:rPr sz="1800" b="1">
-                <a:solidFill>
-                  <a:srgbClr val="222A35"/>
-                </a:solidFill>
-              </a:rPr>
-              <a:t>• Level 1 基线</a:t>
-            </a:r>
-            <a:r>
-              <a:rPr sz="1700">
-                <a:solidFill>
-                  <a:srgbClr val="666666"/>
-                </a:solidFill>
-              </a:rPr>
-              <a:t>　顺序式两步走：前 52% 时间只移动（600 μs），后 48% 只降深。</a:t>
-            </a:r>
-          </a:p>
-          <a:p>
-            <a:pPr>
-              <a:spcAft>
-                <a:spcPts val="600"/>
-              </a:spcAft>
-            </a:pPr>
-            <a:r>
-              <a:rPr sz="1800" b="1">
-                <a:solidFill>
-                  <a:srgbClr val="222A35"/>
-                </a:solidFill>
-              </a:rPr>
-              <a:t>• Level 2 问题</a:t>
-            </a:r>
-            <a:r>
-              <a:rPr sz="1700">
-                <a:solidFill>
-                  <a:srgbClr val="666666"/>
-                </a:solidFill>
-              </a:rPr>
-              <a:t>　允许位置与深度同时变化（重叠），能否把转移从 600 μs 压缩到 400 μs，同时保持或提高 SLM 俘获率、降低末态激发？</a:t>
-            </a:r>
-          </a:p>
-        </p:txBody>
-      </p:sp>
-      <p:sp>
-        <p:nvSpPr>
-          <p:cNvPr id="6" name="Rectangle 5"/>
-          <p:cNvSpPr/>
-          <p:nvPr/>
-        </p:nvSpPr>
-        <p:spPr>
-          <a:xfrm>
-            <a:off x="640080" y="4297680"/>
-            <a:ext cx="10881360" cy="1737360"/>
-          </a:xfrm>
-          <a:prstGeom prst="rect">
-            <a:avLst/>
-          </a:prstGeom>
-          <a:solidFill>
-            <a:srgbClr val="FDF3E7"/>
-          </a:solidFill>
-          <a:ln>
-            <a:solidFill>
-              <a:srgbClr val="E8A860"/>
-            </a:solidFill>
-          </a:ln>
-        </p:spPr>
-        <p:style>
-          <a:lnRef idx="1">
-            <a:schemeClr val="accent1"/>
-          </a:lnRef>
-          <a:fillRef idx="3">
-            <a:schemeClr val="accent1"/>
-          </a:fillRef>
-          <a:effectRef idx="2">
-            <a:schemeClr val="accent1"/>
-          </a:effectRef>
-          <a:fontRef idx="minor">
-            <a:schemeClr val="lt1"/>
-          </a:fontRef>
-        </p:style>
-        <p:txBody>
-          <a:bodyPr rtlCol="0" anchor="ctr"/>
-          <a:lstStyle/>
-          <a:p>
-            <a:pPr algn="ctr"/>
-          </a:p>
-        </p:txBody>
-      </p:sp>
-      <p:sp>
-        <p:nvSpPr>
-          <p:cNvPr id="7" name="TextBox 6"/>
-          <p:cNvSpPr txBox="1"/>
-          <p:nvPr/>
-        </p:nvSpPr>
-        <p:spPr>
-          <a:xfrm>
-            <a:off x="914400" y="4526280"/>
-            <a:ext cx="10332720" cy="1371600"/>
-          </a:xfrm>
-          <a:prstGeom prst="rect">
-            <a:avLst/>
-          </a:prstGeom>
-          <a:noFill/>
-        </p:spPr>
-        <p:txBody>
-          <a:bodyPr wrap="square">
-            <a:spAutoFit/>
-          </a:bodyPr>
-          <a:lstStyle/>
-          <a:p>
-            <a:pPr algn="l"/>
-            <a:r>
-              <a:rPr sz="1400" b="0">
-                <a:solidFill>
-                  <a:srgbClr val="222A35"/>
-                </a:solidFill>
-              </a:rPr>
-              <a:t>方法学底线（本项目的核心价值）</a:t>
-            </a:r>
-          </a:p>
-          <a:p>
-            <a:pPr algn="l"/>
-            <a:r>
-              <a:rPr sz="1400" b="0">
-                <a:solidFill>
-                  <a:srgbClr val="222A35"/>
-                </a:solidFill>
-              </a:rPr>
-              <a:t>· 三批互不重叠的随机样本池，防止蒙特卡洛过拟合</a:t>
-            </a:r>
-          </a:p>
-          <a:p>
-            <a:pPr algn="l"/>
-            <a:r>
-              <a:rPr sz="1400" b="0">
-                <a:solidFill>
-                  <a:srgbClr val="222A35"/>
-                </a:solidFill>
-              </a:rPr>
-              <a:t>· 优化后未优于基线 ≠ 失败：如实报告『未观察到显著提升』，不得用验证集回调参数</a:t>
-            </a:r>
-          </a:p>
-        </p:txBody>
-      </p:sp>
-      <p:sp>
-        <p:nvSpPr>
-          <p:cNvPr id="8" name="TextBox 7"/>
-          <p:cNvSpPr txBox="1"/>
-          <p:nvPr/>
-        </p:nvSpPr>
-        <p:spPr>
-          <a:xfrm>
-            <a:off x="640080" y="6217920"/>
-            <a:ext cx="10881360" cy="365760"/>
-          </a:xfrm>
-          <a:prstGeom prst="rect">
-            <a:avLst/>
-          </a:prstGeom>
-          <a:noFill/>
-        </p:spPr>
-        <p:txBody>
-          <a:bodyPr wrap="square">
-            <a:spAutoFit/>
-          </a:bodyPr>
-          <a:lstStyle/>
-          <a:p>
-            <a:pPr algn="l"/>
-            <a:r>
-              <a:rPr sz="1200" b="0">
-                <a:solidFill>
-                  <a:srgbClr val="666666"/>
-                </a:solidFill>
-              </a:rPr>
-              <a:t>模型边界：一维经典动力学；不含二维/轴向、光子散射、技术噪声、量子内态与多原子相互作用。</a:t>
+              <a:t>Level 1 先移动后降深（600 μs）；Level 2 让移动与降深同步重叠，压缩到 400 μs（提速 33%）。</a:t>
             </a:r>
           </a:p>
         </p:txBody>
@@ -5373,7 +3946,7 @@
         <p:spPr>
           <a:xfrm>
             <a:off x="0" y="0"/>
-            <a:ext cx="12191695" cy="868680"/>
+            <a:ext cx="12191695" cy="786384"/>
           </a:xfrm>
           <a:prstGeom prst="rect">
             <a:avLst/>
@@ -5415,8 +3988,8 @@
         </p:nvSpPr>
         <p:spPr>
           <a:xfrm>
-            <a:off x="457200" y="109728"/>
-            <a:ext cx="11338560" cy="548640"/>
+            <a:off x="457200" y="91440"/>
+            <a:ext cx="11338560" cy="603504"/>
           </a:xfrm>
           <a:prstGeom prst="rect">
             <a:avLst/>
@@ -5429,28 +4002,51 @@
           </a:bodyPr>
           <a:lstStyle/>
           <a:p>
-            <a:pPr algn="l"/>
-            <a:r>
-              <a:rPr sz="2600" b="1">
+            <a:r>
+              <a:rPr sz="2500" b="1">
                 <a:solidFill>
                   <a:srgbClr val="FFFFFF"/>
                 </a:solidFill>
               </a:rPr>
-              <a:t>物理模型（沿用 Level 0/1 已验证实现）</a:t>
-            </a:r>
-          </a:p>
-        </p:txBody>
-      </p:sp>
-      <p:sp>
-        <p:nvSpPr>
-          <p:cNvPr id="4" name="TextBox 3"/>
+              <a:t>物理模型：一维双高斯阱</a:t>
+            </a:r>
+          </a:p>
+        </p:txBody>
+      </p:sp>
+      <p:pic>
+        <p:nvPicPr>
+          <p:cNvPr id="4" name="Picture 3" descr="s02_物理模型.png"/>
+          <p:cNvPicPr>
+            <a:picLocks noChangeAspect="1"/>
+          </p:cNvPicPr>
+          <p:nvPr/>
+        </p:nvPicPr>
+        <p:blipFill>
+          <a:blip r:embed="rId2"/>
+          <a:stretch>
+            <a:fillRect/>
+          </a:stretch>
+        </p:blipFill>
+        <p:spPr>
+          <a:xfrm>
+            <a:off x="274319" y="990785"/>
+            <a:ext cx="11640312" cy="4739269"/>
+          </a:xfrm>
+          <a:prstGeom prst="rect">
+            <a:avLst/>
+          </a:prstGeom>
+        </p:spPr>
+      </p:pic>
+      <p:sp>
+        <p:nvSpPr>
+          <p:cNvPr id="5" name="TextBox 4"/>
           <p:cNvSpPr txBox="1"/>
           <p:nvPr/>
         </p:nvSpPr>
         <p:spPr>
           <a:xfrm>
-            <a:off x="502920" y="566928"/>
-            <a:ext cx="11247120" cy="320040"/>
+            <a:off x="640080" y="5989320"/>
+            <a:ext cx="10881360" cy="548640"/>
           </a:xfrm>
           <a:prstGeom prst="rect">
             <a:avLst/>
@@ -5463,352 +4059,14 @@
           </a:bodyPr>
           <a:lstStyle/>
           <a:p>
-            <a:pPr algn="l"/>
-            <a:r>
-              <a:rPr sz="1300" b="0">
-                <a:solidFill>
-                  <a:srgbClr val="DDE8F5"/>
-                </a:solidFill>
-              </a:rPr>
-              <a:t>一维焦平面径向高斯势</a:t>
-            </a:r>
-          </a:p>
-        </p:txBody>
-      </p:sp>
-      <p:sp>
-        <p:nvSpPr>
-          <p:cNvPr id="5" name="TextBox 4"/>
-          <p:cNvSpPr txBox="1"/>
-          <p:nvPr/>
-        </p:nvSpPr>
-        <p:spPr>
-          <a:xfrm>
-            <a:off x="640080" y="1234440"/>
-            <a:ext cx="6035040" cy="4023360"/>
-          </a:xfrm>
-          <a:prstGeom prst="rect">
-            <a:avLst/>
-          </a:prstGeom>
-          <a:noFill/>
-        </p:spPr>
-        <p:txBody>
-          <a:bodyPr wrap="square">
-            <a:spAutoFit/>
-          </a:bodyPr>
-          <a:lstStyle/>
-          <a:p>
-            <a:pPr>
-              <a:spcAft>
-                <a:spcPts val="600"/>
-              </a:spcAft>
-            </a:pPr>
-            <a:r>
-              <a:rPr sz="1500" b="1">
-                <a:solidFill>
-                  <a:srgbClr val="222A35"/>
-                </a:solidFill>
-              </a:rPr>
-              <a:t>• SLM 静止阱</a:t>
-            </a:r>
+            <a:pPr algn="ctr"/>
             <a:r>
               <a:rPr sz="1400">
                 <a:solidFill>
                   <a:srgbClr val="666666"/>
                 </a:solidFill>
               </a:rPr>
-              <a:t>　U_SLM(x) = −D_SLM·exp(−2x²/w²)，D_SLM = 140 μK，w = 1.17 μm</a:t>
-            </a:r>
-          </a:p>
-          <a:p>
-            <a:pPr>
-              <a:spcAft>
-                <a:spcPts val="600"/>
-              </a:spcAft>
-            </a:pPr>
-            <a:r>
-              <a:rPr sz="1500" b="1">
-                <a:solidFill>
-                  <a:srgbClr val="222A35"/>
-                </a:solidFill>
-              </a:rPr>
-              <a:t>• AOD 时变阱</a:t>
-            </a:r>
-            <a:r>
-              <a:rPr sz="1400">
-                <a:solidFill>
-                  <a:srgbClr val="666666"/>
-                </a:solidFill>
-              </a:rPr>
-              <a:t>　U_AOD(x,t) = −D(t)·exp(−2[x−c(t)]²/w²)，初始 D₀ = 280 μK，c₀ = 2.4 μm</a:t>
-            </a:r>
-          </a:p>
-          <a:p>
-            <a:pPr>
-              <a:spcAft>
-                <a:spcPts val="600"/>
-              </a:spcAft>
-            </a:pPr>
-            <a:r>
-              <a:rPr sz="1500" b="1">
-                <a:solidFill>
-                  <a:srgbClr val="222A35"/>
-                </a:solidFill>
-              </a:rPr>
-              <a:t>• 动力学</a:t>
-            </a:r>
-            <a:r>
-              <a:rPr sz="1400">
-                <a:solidFill>
-                  <a:srgbClr val="666666"/>
-                </a:solidFill>
-              </a:rPr>
-              <a:t>　时变 velocity-Verlet 推进；转移后追加 100 μs 纯 SLM 保持段</a:t>
-            </a:r>
-          </a:p>
-          <a:p>
-            <a:pPr>
-              <a:spcAft>
-                <a:spcPts val="600"/>
-              </a:spcAft>
-            </a:pPr>
-            <a:r>
-              <a:rPr sz="1500" b="1">
-                <a:solidFill>
-                  <a:srgbClr val="222A35"/>
-                </a:solidFill>
-              </a:rPr>
-              <a:t>• 俘获判据</a:t>
-            </a:r>
-            <a:r>
-              <a:rPr sz="1400">
-                <a:solidFill>
-                  <a:srgbClr val="666666"/>
-                </a:solidFill>
-              </a:rPr>
-              <a:t>　末态 SLM 单阱能量 E_f &lt; 0 ⇒ captured（严格符号判据）</a:t>
-            </a:r>
-          </a:p>
-        </p:txBody>
-      </p:sp>
-      <p:sp>
-        <p:nvSpPr>
-          <p:cNvPr id="6" name="Rectangle 5"/>
-          <p:cNvSpPr/>
-          <p:nvPr/>
-        </p:nvSpPr>
-        <p:spPr>
-          <a:xfrm>
-            <a:off x="6858000" y="1234440"/>
-            <a:ext cx="4754880" cy="4023360"/>
-          </a:xfrm>
-          <a:prstGeom prst="rect">
-            <a:avLst/>
-          </a:prstGeom>
-          <a:solidFill>
-            <a:srgbClr val="EAF3FB"/>
-          </a:solidFill>
-          <a:ln>
-            <a:solidFill>
-              <a:srgbClr val="1F77B4"/>
-            </a:solidFill>
-          </a:ln>
-        </p:spPr>
-        <p:style>
-          <a:lnRef idx="1">
-            <a:schemeClr val="accent1"/>
-          </a:lnRef>
-          <a:fillRef idx="3">
-            <a:schemeClr val="accent1"/>
-          </a:fillRef>
-          <a:effectRef idx="2">
-            <a:schemeClr val="accent1"/>
-          </a:effectRef>
-          <a:fontRef idx="minor">
-            <a:schemeClr val="lt1"/>
-          </a:fontRef>
-        </p:style>
-        <p:txBody>
-          <a:bodyPr rtlCol="0" anchor="ctr"/>
-          <a:lstStyle/>
-          <a:p>
-            <a:pPr algn="ctr"/>
-          </a:p>
-        </p:txBody>
-      </p:sp>
-      <p:sp>
-        <p:nvSpPr>
-          <p:cNvPr id="7" name="TextBox 6"/>
-          <p:cNvSpPr txBox="1"/>
-          <p:nvPr/>
-        </p:nvSpPr>
-        <p:spPr>
-          <a:xfrm>
-            <a:off x="7132320" y="1417320"/>
-            <a:ext cx="4297680" cy="3657600"/>
-          </a:xfrm>
-          <a:prstGeom prst="rect">
-            <a:avLst/>
-          </a:prstGeom>
-          <a:noFill/>
-        </p:spPr>
-        <p:txBody>
-          <a:bodyPr wrap="square">
-            <a:spAutoFit/>
-          </a:bodyPr>
-          <a:lstStyle/>
-          <a:p>
-            <a:pPr algn="l"/>
-            <a:r>
-              <a:rPr sz="1400" b="0">
-                <a:solidFill>
-                  <a:srgbClr val="222A35"/>
-                </a:solidFill>
-              </a:rPr>
-              <a:t>显式时变势中的功-能检查</a:t>
-            </a:r>
-          </a:p>
-          <a:p>
-            <a:pPr algn="l"/>
-            <a:r>
-              <a:rPr sz="1400" b="0">
-                <a:solidFill>
-                  <a:srgbClr val="222A35"/>
-                </a:solidFill>
-              </a:rPr>
-              <a:t/>
-            </a:r>
-          </a:p>
-          <a:p>
-            <a:pPr algn="l"/>
-            <a:r>
-              <a:rPr sz="1400" b="0">
-                <a:solidFill>
-                  <a:srgbClr val="222A35"/>
-                </a:solidFill>
-              </a:rPr>
-              <a:t>转移期间机械能不守恒——外部控制在做功：</a:t>
-            </a:r>
-          </a:p>
-          <a:p>
-            <a:pPr algn="l"/>
-            <a:r>
-              <a:rPr sz="1400" b="0">
-                <a:solidFill>
-                  <a:srgbClr val="222A35"/>
-                </a:solidFill>
-              </a:rPr>
-              <a:t/>
-            </a:r>
-          </a:p>
-          <a:p>
-            <a:pPr algn="l"/>
-            <a:r>
-              <a:rPr sz="1400" b="0">
-                <a:solidFill>
-                  <a:srgbClr val="222A35"/>
-                </a:solidFill>
-              </a:rPr>
-              <a:t>dE/dt = ∂U_AOD/∂t = 深度功 + 移动功</a:t>
-            </a:r>
-          </a:p>
-          <a:p>
-            <a:pPr algn="l"/>
-            <a:r>
-              <a:rPr sz="1400" b="0">
-                <a:solidFill>
-                  <a:srgbClr val="222A35"/>
-                </a:solidFill>
-              </a:rPr>
-              <a:t/>
-            </a:r>
-          </a:p>
-          <a:p>
-            <a:pPr algn="l"/>
-            <a:r>
-              <a:rPr sz="1400" b="0">
-                <a:solidFill>
-                  <a:srgbClr val="222A35"/>
-                </a:solidFill>
-              </a:rPr>
-              <a:t>数值上验证：</a:t>
-            </a:r>
-          </a:p>
-          <a:p>
-            <a:pPr algn="l"/>
-            <a:r>
-              <a:rPr sz="1400" b="0">
-                <a:solidFill>
-                  <a:srgbClr val="222A35"/>
-                </a:solidFill>
-              </a:rPr>
-              <a:t>R_W = E(t) − E(0) − W_ext(t) ≈ 0</a:t>
-            </a:r>
-          </a:p>
-          <a:p>
-            <a:pPr algn="l"/>
-            <a:r>
-              <a:rPr sz="1400" b="0">
-                <a:solidFill>
-                  <a:srgbClr val="222A35"/>
-                </a:solidFill>
-              </a:rPr>
-              <a:t/>
-            </a:r>
-          </a:p>
-          <a:p>
-            <a:pPr algn="l"/>
-            <a:r>
-              <a:rPr sz="1400" b="0">
-                <a:solidFill>
-                  <a:srgbClr val="222A35"/>
-                </a:solidFill>
-              </a:rPr>
-              <a:t>残差实测 ≪ 1e-3（相对阱深），</a:t>
-            </a:r>
-          </a:p>
-          <a:p>
-            <a:pPr algn="l"/>
-            <a:r>
-              <a:rPr sz="1400" b="0">
-                <a:solidFill>
-                  <a:srgbClr val="222A35"/>
-                </a:solidFill>
-              </a:rPr>
-              <a:t>保持段能量仅有界振荡、无漂移</a:t>
-            </a:r>
-          </a:p>
-        </p:txBody>
-      </p:sp>
-      <p:sp>
-        <p:nvSpPr>
-          <p:cNvPr id="8" name="TextBox 7"/>
-          <p:cNvSpPr txBox="1"/>
-          <p:nvPr/>
-        </p:nvSpPr>
-        <p:spPr>
-          <a:xfrm>
-            <a:off x="640080" y="5623560"/>
-            <a:ext cx="10972800" cy="731520"/>
-          </a:xfrm>
-          <a:prstGeom prst="rect">
-            <a:avLst/>
-          </a:prstGeom>
-          <a:noFill/>
-        </p:spPr>
-        <p:txBody>
-          <a:bodyPr wrap="square">
-            <a:spAutoFit/>
-          </a:bodyPr>
-          <a:lstStyle/>
-          <a:p>
-            <a:pPr algn="l"/>
-            <a:r>
-              <a:rPr sz="1300" b="0">
-                <a:solidFill>
-                  <a:srgbClr val="666666"/>
-                </a:solidFill>
-              </a:rPr>
-              <a:t>初态：5 μK 简谐近似热分布抽样 + 完整高斯阱束缚拒绝（E_AOD&lt;0）；记录验收率、均值、标准差与种子。w_ADM=1.17 μm 为与 SLM 后孔径匹配的假设值。</a:t>
+              <a:t>280 μK AOD 阱载着 5 μK 铯原子移向 140 μK 静止 SLM 阱并逐渐变浅；末态 E_f &lt; 0 判定俘获。</a:t>
             </a:r>
           </a:p>
         </p:txBody>
@@ -5840,7 +4098,7 @@
         <p:spPr>
           <a:xfrm>
             <a:off x="0" y="0"/>
-            <a:ext cx="12191695" cy="868680"/>
+            <a:ext cx="12191695" cy="786384"/>
           </a:xfrm>
           <a:prstGeom prst="rect">
             <a:avLst/>
@@ -5882,8 +4140,8 @@
         </p:nvSpPr>
         <p:spPr>
           <a:xfrm>
-            <a:off x="457200" y="109728"/>
-            <a:ext cx="11338560" cy="548640"/>
+            <a:off x="457200" y="91440"/>
+            <a:ext cx="11338560" cy="603504"/>
           </a:xfrm>
           <a:prstGeom prst="rect">
             <a:avLst/>
@@ -5896,55 +4154,20 @@
           </a:bodyPr>
           <a:lstStyle/>
           <a:p>
-            <a:pPr algn="l"/>
-            <a:r>
-              <a:rPr sz="2600" b="1">
+            <a:r>
+              <a:rPr sz="2500" b="1">
                 <a:solidFill>
                   <a:srgbClr val="FFFFFF"/>
                 </a:solidFill>
               </a:rPr>
-              <a:t>方法总览：三池隔离 + 公共随机数</a:t>
-            </a:r>
-          </a:p>
-        </p:txBody>
-      </p:sp>
-      <p:sp>
-        <p:nvSpPr>
-          <p:cNvPr id="4" name="TextBox 3"/>
-          <p:cNvSpPr txBox="1"/>
-          <p:nvPr/>
-        </p:nvSpPr>
-        <p:spPr>
-          <a:xfrm>
-            <a:off x="502920" y="566928"/>
-            <a:ext cx="11247120" cy="320040"/>
-          </a:xfrm>
-          <a:prstGeom prst="rect">
-            <a:avLst/>
-          </a:prstGeom>
-          <a:noFill/>
-        </p:spPr>
-        <p:txBody>
-          <a:bodyPr wrap="square">
-            <a:spAutoFit/>
-          </a:bodyPr>
-          <a:lstStyle/>
-          <a:p>
-            <a:pPr algn="l"/>
-            <a:r>
-              <a:rPr sz="1300" b="0">
-                <a:solidFill>
-                  <a:srgbClr val="DDE8F5"/>
-                </a:solidFill>
-              </a:rPr>
-              <a:t>防止用验证集『作弊』的完整闭环</a:t>
+              <a:t>方法：三池隔离 + 公共随机数</a:t>
             </a:r>
           </a:p>
         </p:txBody>
       </p:sp>
       <p:pic>
         <p:nvPicPr>
-          <p:cNvPr id="5" name="Picture 4" descr="01_流程总览.png"/>
+          <p:cNvPr id="4" name="Picture 3" descr="s03_方法.png"/>
           <p:cNvPicPr>
             <a:picLocks noChangeAspect="1"/>
           </p:cNvPicPr>
@@ -5958,14 +4181,48 @@
         </p:blipFill>
         <p:spPr>
           <a:xfrm>
-            <a:off x="997771" y="914400"/>
-            <a:ext cx="10165976" cy="5760720"/>
+            <a:off x="274319" y="990785"/>
+            <a:ext cx="11640312" cy="4739269"/>
           </a:xfrm>
           <a:prstGeom prst="rect">
             <a:avLst/>
           </a:prstGeom>
         </p:spPr>
       </p:pic>
+      <p:sp>
+        <p:nvSpPr>
+          <p:cNvPr id="5" name="TextBox 4"/>
+          <p:cNvSpPr txBox="1"/>
+          <p:nvPr/>
+        </p:nvSpPr>
+        <p:spPr>
+          <a:xfrm>
+            <a:off x="640080" y="5989320"/>
+            <a:ext cx="10881360" cy="548640"/>
+          </a:xfrm>
+          <a:prstGeom prst="rect">
+            <a:avLst/>
+          </a:prstGeom>
+          <a:noFill/>
+        </p:spPr>
+        <p:txBody>
+          <a:bodyPr wrap="square">
+            <a:spAutoFit/>
+          </a:bodyPr>
+          <a:lstStyle/>
+          <a:p>
+            <a:pPr algn="ctr"/>
+            <a:r>
+              <a:rPr sz="1400">
+                <a:solidFill>
+                  <a:srgbClr val="666666"/>
+                </a:solidFill>
+              </a:rPr>
+              <a:t>三批互不重叠的样本池各司其职，validation 只报告一次；所有波形用同一组初态（CRN）比较。</a:t>
+            </a:r>
+          </a:p>
+        </p:txBody>
+      </p:sp>
     </p:spTree>
   </p:cSld>
   <p:clrMapOvr>
@@ -5993,7 +4250,7 @@
         <p:spPr>
           <a:xfrm>
             <a:off x="0" y="0"/>
-            <a:ext cx="12191695" cy="868680"/>
+            <a:ext cx="12191695" cy="786384"/>
           </a:xfrm>
           <a:prstGeom prst="rect">
             <a:avLst/>
@@ -6035,8 +4292,8 @@
         </p:nvSpPr>
         <p:spPr>
           <a:xfrm>
-            <a:off x="457200" y="109728"/>
-            <a:ext cx="11338560" cy="548640"/>
+            <a:off x="457200" y="91440"/>
+            <a:ext cx="11338560" cy="603504"/>
           </a:xfrm>
           <a:prstGeom prst="rect">
             <a:avLst/>
@@ -6049,55 +4306,20 @@
           </a:bodyPr>
           <a:lstStyle/>
           <a:p>
-            <a:pPr algn="l"/>
-            <a:r>
-              <a:rPr sz="2600" b="1">
+            <a:r>
+              <a:rPr sz="2500" b="1">
                 <a:solidFill>
                   <a:srgbClr val="FFFFFF"/>
                 </a:solidFill>
               </a:rPr>
-              <a:t>三类主波形</a:t>
-            </a:r>
-          </a:p>
-        </p:txBody>
-      </p:sp>
-      <p:sp>
-        <p:nvSpPr>
-          <p:cNvPr id="4" name="TextBox 3"/>
-          <p:cNvSpPr txBox="1"/>
-          <p:nvPr/>
-        </p:nvSpPr>
-        <p:spPr>
-          <a:xfrm>
-            <a:off x="502920" y="566928"/>
-            <a:ext cx="11247120" cy="320040"/>
-          </a:xfrm>
-          <a:prstGeom prst="rect">
-            <a:avLst/>
-          </a:prstGeom>
-          <a:noFill/>
-        </p:spPr>
-        <p:txBody>
-          <a:bodyPr wrap="square">
-            <a:spAutoFit/>
-          </a:bodyPr>
-          <a:lstStyle/>
-          <a:p>
-            <a:pPr algn="l"/>
-            <a:r>
-              <a:rPr sz="1300" b="0">
-                <a:solidFill>
-                  <a:srgbClr val="DDE8F5"/>
-                </a:solidFill>
-              </a:rPr>
-              <a:t>优化器调整的 5 个参数：移动窗口×2、降深窗口×2、降深幂次</a:t>
+              <a:t>三类波形：『同步』= 重叠 39%</a:t>
             </a:r>
           </a:p>
         </p:txBody>
       </p:sp>
       <p:pic>
         <p:nvPicPr>
-          <p:cNvPr id="5" name="Picture 4" descr="02_波形对比.png"/>
+          <p:cNvPr id="4" name="Picture 3" descr="s04_波形对比.png"/>
           <p:cNvPicPr>
             <a:picLocks noChangeAspect="1"/>
           </p:cNvPicPr>
@@ -6111,8 +4333,8 @@
         </p:blipFill>
         <p:spPr>
           <a:xfrm>
-            <a:off x="2240280" y="914400"/>
-            <a:ext cx="7680960" cy="4937760"/>
+            <a:off x="274319" y="990785"/>
+            <a:ext cx="11640312" cy="4739269"/>
           </a:xfrm>
           <a:prstGeom prst="rect">
             <a:avLst/>
@@ -6121,14 +4343,14 @@
       </p:pic>
       <p:sp>
         <p:nvSpPr>
-          <p:cNvPr id="6" name="TextBox 5"/>
+          <p:cNvPr id="5" name="TextBox 4"/>
           <p:cNvSpPr txBox="1"/>
           <p:nvPr/>
         </p:nvSpPr>
         <p:spPr>
           <a:xfrm>
             <a:off x="640080" y="5989320"/>
-            <a:ext cx="10972800" cy="640080"/>
+            <a:ext cx="10881360" cy="548640"/>
           </a:xfrm>
           <a:prstGeom prst="rect">
             <a:avLst/>
@@ -6141,14 +4363,14 @@
           </a:bodyPr>
           <a:lstStyle/>
           <a:p>
-            <a:pPr algn="l"/>
-            <a:r>
-              <a:rPr sz="1300" b="0">
+            <a:pPr algn="ctr"/>
+            <a:r>
+              <a:rPr sz="1400">
                 <a:solidFill>
                   <a:srgbClr val="666666"/>
                 </a:solidFill>
               </a:rPr>
-              <a:t>『同步』的含义：优化波形让移动几乎贯穿全程（s∈[0.019, 1]），降深在 s≥0.607 才开始——移动与降深重叠约 39% 的时间；约束保证单调、无过冲、端点速度/加速度为零。</a:t>
+              <a:t>优化波形移动几乎贯穿全程（s ≥ 0.019），降深 s ≥ 0.607 才开始——移动与降深重叠约 39% 的时间。</a:t>
             </a:r>
           </a:p>
         </p:txBody>
@@ -6180,7 +4402,7 @@
         <p:spPr>
           <a:xfrm>
             <a:off x="0" y="0"/>
-            <a:ext cx="12191695" cy="868680"/>
+            <a:ext cx="12191695" cy="786384"/>
           </a:xfrm>
           <a:prstGeom prst="rect">
             <a:avLst/>
@@ -6222,8 +4444,8 @@
         </p:nvSpPr>
         <p:spPr>
           <a:xfrm>
-            <a:off x="457200" y="109728"/>
-            <a:ext cx="11338560" cy="548640"/>
+            <a:off x="457200" y="91440"/>
+            <a:ext cx="11338560" cy="603504"/>
           </a:xfrm>
           <a:prstGeom prst="rect">
             <a:avLst/>
@@ -6236,21 +4458,20 @@
           </a:bodyPr>
           <a:lstStyle/>
           <a:p>
-            <a:pPr algn="l"/>
-            <a:r>
-              <a:rPr sz="2600" b="1">
+            <a:r>
+              <a:rPr sz="2500" b="1">
                 <a:solidFill>
                   <a:srgbClr val="FFFFFF"/>
                 </a:solidFill>
               </a:rPr>
-              <a:t>势场演化：原子如何被『倒』进 SLM 阱</a:t>
+              <a:t>势场演化：原子被『倒』进 SLM</a:t>
             </a:r>
           </a:p>
         </p:txBody>
       </p:sp>
       <p:pic>
         <p:nvPicPr>
-          <p:cNvPr id="4" name="Picture 3" descr="03_势能剖面演化.png"/>
+          <p:cNvPr id="4" name="Picture 3" descr="s05_势场演化.png"/>
           <p:cNvPicPr>
             <a:picLocks noChangeAspect="1"/>
           </p:cNvPicPr>
@@ -6264,14 +4485,48 @@
         </p:blipFill>
         <p:spPr>
           <a:xfrm>
-            <a:off x="228600" y="1212924"/>
-            <a:ext cx="11704320" cy="5163670"/>
+            <a:off x="274319" y="990785"/>
+            <a:ext cx="11640312" cy="4739269"/>
           </a:xfrm>
           <a:prstGeom prst="rect">
             <a:avLst/>
           </a:prstGeom>
         </p:spPr>
       </p:pic>
+      <p:sp>
+        <p:nvSpPr>
+          <p:cNvPr id="5" name="TextBox 4"/>
+          <p:cNvSpPr txBox="1"/>
+          <p:nvPr/>
+        </p:nvSpPr>
+        <p:spPr>
+          <a:xfrm>
+            <a:off x="640080" y="5989320"/>
+            <a:ext cx="10881360" cy="548640"/>
+          </a:xfrm>
+          <a:prstGeom prst="rect">
+            <a:avLst/>
+          </a:prstGeom>
+          <a:noFill/>
+        </p:spPr>
+        <p:txBody>
+          <a:bodyPr wrap="square">
+            <a:spAutoFit/>
+          </a:bodyPr>
+          <a:lstStyle/>
+          <a:p>
+            <a:pPr algn="ctr"/>
+            <a:r>
+              <a:rPr sz="1400">
+                <a:solidFill>
+                  <a:srgbClr val="666666"/>
+                </a:solidFill>
+              </a:rPr>
+              <a:t>AOD 阱边移动边变浅，阱底（原子跟随）一路滑向 SLM；交接时刻 AOD 深度恰好为 0。</a:t>
+            </a:r>
+          </a:p>
+        </p:txBody>
+      </p:sp>
     </p:spTree>
   </p:cSld>
   <p:clrMapOvr>
@@ -6299,7 +4554,7 @@
         <p:spPr>
           <a:xfrm>
             <a:off x="0" y="0"/>
-            <a:ext cx="12191695" cy="868680"/>
+            <a:ext cx="12191695" cy="786384"/>
           </a:xfrm>
           <a:prstGeom prst="rect">
             <a:avLst/>
@@ -6341,8 +4596,8 @@
         </p:nvSpPr>
         <p:spPr>
           <a:xfrm>
-            <a:off x="457200" y="109728"/>
-            <a:ext cx="11338560" cy="548640"/>
+            <a:off x="457200" y="91440"/>
+            <a:ext cx="11338560" cy="603504"/>
           </a:xfrm>
           <a:prstGeom prst="rect">
             <a:avLst/>
@@ -6355,55 +4610,20 @@
           </a:bodyPr>
           <a:lstStyle/>
           <a:p>
-            <a:pPr algn="l"/>
-            <a:r>
-              <a:rPr sz="2600" b="1">
+            <a:r>
+              <a:rPr sz="2500" b="1">
                 <a:solidFill>
                   <a:srgbClr val="FFFFFF"/>
                 </a:solidFill>
               </a:rPr>
-              <a:t>优化过程</a:t>
-            </a:r>
-          </a:p>
-        </p:txBody>
-      </p:sp>
-      <p:sp>
-        <p:nvSpPr>
-          <p:cNvPr id="4" name="TextBox 3"/>
-          <p:cNvSpPr txBox="1"/>
-          <p:nvPr/>
-        </p:nvSpPr>
-        <p:spPr>
-          <a:xfrm>
-            <a:off x="502920" y="566928"/>
-            <a:ext cx="11247120" cy="320040"/>
-          </a:xfrm>
-          <a:prstGeom prst="rect">
-            <a:avLst/>
-          </a:prstGeom>
-          <a:noFill/>
-        </p:spPr>
-        <p:txBody>
-          <a:bodyPr wrap="square">
-            <a:spAutoFit/>
-          </a:bodyPr>
-          <a:lstStyle/>
-          <a:p>
-            <a:pPr algn="l"/>
-            <a:r>
-              <a:rPr sz="1300" b="0">
-                <a:solidFill>
-                  <a:srgbClr val="DDE8F5"/>
-                </a:solidFill>
-              </a:rPr>
-              <a:t>拉丁超立方探索 → 精修选择 → PCHIP 样条 → 冻结</a:t>
+              <a:t>噪声模型：三通道常数功率加热</a:t>
             </a:r>
           </a:p>
         </p:txBody>
       </p:sp>
       <p:pic>
         <p:nvPicPr>
-          <p:cNvPr id="5" name="Picture 4" descr="04_优化过程.png"/>
+          <p:cNvPr id="4" name="Picture 3" descr="s11_噪声模型.png"/>
           <p:cNvPicPr>
             <a:picLocks noChangeAspect="1"/>
           </p:cNvPicPr>
@@ -6417,8 +4637,8 @@
         </p:blipFill>
         <p:spPr>
           <a:xfrm>
-            <a:off x="228600" y="987878"/>
-            <a:ext cx="8138160" cy="5522322"/>
+            <a:off x="274319" y="990785"/>
+            <a:ext cx="11640312" cy="4739269"/>
           </a:xfrm>
           <a:prstGeom prst="rect">
             <a:avLst/>
@@ -6427,59 +4647,14 @@
       </p:pic>
       <p:sp>
         <p:nvSpPr>
-          <p:cNvPr id="6" name="Rectangle 5"/>
-          <p:cNvSpPr/>
-          <p:nvPr/>
-        </p:nvSpPr>
-        <p:spPr>
-          <a:xfrm>
-            <a:off x="8503920" y="1097280"/>
-            <a:ext cx="3383280" cy="4937760"/>
-          </a:xfrm>
-          <a:prstGeom prst="rect">
-            <a:avLst/>
-          </a:prstGeom>
-          <a:solidFill>
-            <a:srgbClr val="EEF8EE"/>
-          </a:solidFill>
-          <a:ln>
-            <a:solidFill>
-              <a:srgbClr val="2CA02C"/>
-            </a:solidFill>
-          </a:ln>
-        </p:spPr>
-        <p:style>
-          <a:lnRef idx="1">
-            <a:schemeClr val="accent1"/>
-          </a:lnRef>
-          <a:fillRef idx="3">
-            <a:schemeClr val="accent1"/>
-          </a:fillRef>
-          <a:effectRef idx="2">
-            <a:schemeClr val="accent1"/>
-          </a:effectRef>
-          <a:fontRef idx="minor">
-            <a:schemeClr val="lt1"/>
-          </a:fontRef>
-        </p:style>
-        <p:txBody>
-          <a:bodyPr rtlCol="0" anchor="ctr"/>
-          <a:lstStyle/>
-          <a:p>
-            <a:pPr algn="ctr"/>
-          </a:p>
-        </p:txBody>
-      </p:sp>
-      <p:sp>
-        <p:nvSpPr>
-          <p:cNvPr id="7" name="TextBox 6"/>
+          <p:cNvPr id="5" name="TextBox 4"/>
           <p:cNvSpPr txBox="1"/>
           <p:nvPr/>
         </p:nvSpPr>
         <p:spPr>
           <a:xfrm>
-            <a:off x="8686800" y="1280160"/>
-            <a:ext cx="3017520" cy="4572000"/>
+            <a:off x="640080" y="5989320"/>
+            <a:ext cx="10881360" cy="548640"/>
           </a:xfrm>
           <a:prstGeom prst="rect">
             <a:avLst/>
@@ -6492,190 +4667,14 @@
           </a:bodyPr>
           <a:lstStyle/>
           <a:p>
-            <a:pPr algn="l"/>
-            <a:r>
-              <a:rPr sz="1300" b="0">
+            <a:pPr algn="ctr"/>
+            <a:r>
+              <a:rPr sz="1400">
                 <a:solidFill>
-                  <a:srgbClr val="222A35"/>
+                  <a:srgbClr val="666666"/>
                 </a:solidFill>
               </a:rPr>
-              <a:t>分阶段预算</a:t>
-            </a:r>
-          </a:p>
-          <a:p>
-            <a:pPr algn="l"/>
-            <a:r>
-              <a:rPr sz="1300" b="0">
-                <a:solidFill>
-                  <a:srgbClr val="222A35"/>
-                </a:solidFill>
-              </a:rPr>
-              <a:t/>
-            </a:r>
-          </a:p>
-          <a:p>
-            <a:pPr algn="l"/>
-            <a:r>
-              <a:rPr sz="1300" b="0">
-                <a:solidFill>
-                  <a:srgbClr val="222A35"/>
-                </a:solidFill>
-              </a:rPr>
-              <a:t>阶段1：128 shots</a:t>
-            </a:r>
-          </a:p>
-          <a:p>
-            <a:pPr algn="l"/>
-            <a:r>
-              <a:rPr sz="1300" b="0">
-                <a:solidFill>
-                  <a:srgbClr val="222A35"/>
-                </a:solidFill>
-              </a:rPr>
-              <a:t>LHS 探索 192 候选</a:t>
-            </a:r>
-          </a:p>
-          <a:p>
-            <a:pPr algn="l"/>
-            <a:r>
-              <a:rPr sz="1300" b="0">
-                <a:solidFill>
-                  <a:srgbClr val="222A35"/>
-                </a:solidFill>
-              </a:rPr>
-              <a:t>（后续入围/精修/样条 65）</a:t>
-            </a:r>
-          </a:p>
-          <a:p>
-            <a:pPr algn="l"/>
-            <a:r>
-              <a:rPr sz="1300" b="0">
-                <a:solidFill>
-                  <a:srgbClr val="222A35"/>
-                </a:solidFill>
-              </a:rPr>
-              <a:t/>
-            </a:r>
-          </a:p>
-          <a:p>
-            <a:pPr algn="l"/>
-            <a:r>
-              <a:rPr sz="1300" b="0">
-                <a:solidFill>
-                  <a:srgbClr val="222A35"/>
-                </a:solidFill>
-              </a:rPr>
-              <a:t>阶段2：512 shots</a:t>
-            </a:r>
-          </a:p>
-          <a:p>
-            <a:pPr algn="l"/>
-            <a:r>
-              <a:rPr sz="1300" b="0">
-                <a:solidFill>
-                  <a:srgbClr val="222A35"/>
-                </a:solidFill>
-              </a:rPr>
-              <a:t>前 8 名入围精修</a:t>
-            </a:r>
-          </a:p>
-          <a:p>
-            <a:pPr algn="l"/>
-            <a:r>
-              <a:rPr sz="1300" b="0">
-                <a:solidFill>
-                  <a:srgbClr val="222A35"/>
-                </a:solidFill>
-              </a:rPr>
-              <a:t>+ 8 控制点单调样条</a:t>
-            </a:r>
-          </a:p>
-          <a:p>
-            <a:pPr algn="l"/>
-            <a:r>
-              <a:rPr sz="1300" b="0">
-                <a:solidFill>
-                  <a:srgbClr val="222A35"/>
-                </a:solidFill>
-              </a:rPr>
-              <a:t/>
-            </a:r>
-          </a:p>
-          <a:p>
-            <a:pPr algn="l"/>
-            <a:r>
-              <a:rPr sz="1300" b="0">
-                <a:solidFill>
-                  <a:srgbClr val="222A35"/>
-                </a:solidFill>
-              </a:rPr>
-              <a:t>冻结：唯一波形写入</a:t>
-            </a:r>
-          </a:p>
-          <a:p>
-            <a:pPr algn="l"/>
-            <a:r>
-              <a:rPr sz="1300" b="0">
-                <a:solidFill>
-                  <a:srgbClr val="222A35"/>
-                </a:solidFill>
-              </a:rPr>
-              <a:t>best_waveform.yaml</a:t>
-            </a:r>
-          </a:p>
-          <a:p>
-            <a:pPr algn="l"/>
-            <a:r>
-              <a:rPr sz="1300" b="0">
-                <a:solidFill>
-                  <a:srgbClr val="222A35"/>
-                </a:solidFill>
-              </a:rPr>
-              <a:t/>
-            </a:r>
-          </a:p>
-          <a:p>
-            <a:pPr algn="l"/>
-            <a:r>
-              <a:rPr sz="1300" b="0">
-                <a:solidFill>
-                  <a:srgbClr val="222A35"/>
-                </a:solidFill>
-              </a:rPr>
-              <a:t>目标 = 俘获率(主)</a:t>
-            </a:r>
-          </a:p>
-          <a:p>
-            <a:pPr algn="l"/>
-            <a:r>
-              <a:rPr sz="1300" b="0">
-                <a:solidFill>
-                  <a:srgbClr val="222A35"/>
-                </a:solidFill>
-              </a:rPr>
-              <a:t>+ 裕量分位数</a:t>
-            </a:r>
-          </a:p>
-          <a:p>
-            <a:pPr algn="l"/>
-            <a:r>
-              <a:rPr sz="1300" b="0">
-                <a:solidFill>
-                  <a:srgbClr val="222A35"/>
-                </a:solidFill>
-              </a:rPr>
-              <a:t>+ 末态激发 + 光滑度</a:t>
-            </a:r>
-          </a:p>
-          <a:p>
-            <a:pPr algn="l"/>
-            <a:r>
-              <a:rPr sz="1300" b="0">
-                <a:solidFill>
-                  <a:srgbClr val="222A35"/>
-                </a:solidFill>
-              </a:rPr>
-              <a:t>（各组成项分开保存）</a:t>
+              <a:t>系综平均功率的确定性注入（无随机性）：反冲 / 强度（线性化）/ 指向三通道均为常数功率，注入能量计入功-能账本 ΔE = W_ext + W_noise + R_W。</a:t>
             </a:r>
           </a:p>
         </p:txBody>
@@ -6707,7 +4706,7 @@
         <p:spPr>
           <a:xfrm>
             <a:off x="0" y="0"/>
-            <a:ext cx="12191695" cy="868680"/>
+            <a:ext cx="12191695" cy="786384"/>
           </a:xfrm>
           <a:prstGeom prst="rect">
             <a:avLst/>
@@ -6749,8 +4748,8 @@
         </p:nvSpPr>
         <p:spPr>
           <a:xfrm>
-            <a:off x="457200" y="109728"/>
-            <a:ext cx="11338560" cy="548640"/>
+            <a:off x="457200" y="91440"/>
+            <a:ext cx="11338560" cy="603504"/>
           </a:xfrm>
           <a:prstGeom prst="rect">
             <a:avLst/>
@@ -6763,21 +4762,20 @@
           </a:bodyPr>
           <a:lstStyle/>
           <a:p>
-            <a:pPr algn="l"/>
-            <a:r>
-              <a:rPr sz="2600" b="1">
+            <a:r>
+              <a:rPr sz="2500" b="1">
                 <a:solidFill>
                   <a:srgbClr val="FFFFFF"/>
                 </a:solidFill>
               </a:rPr>
-              <a:t>独立验证（2000 shots × 3 波形，同一初态数组）</a:t>
+              <a:t>噪声 × 速度：×1000 才有影响，参量主导</a:t>
             </a:r>
           </a:p>
         </p:txBody>
       </p:sp>
       <p:pic>
         <p:nvPicPr>
-          <p:cNvPr id="4" name="Picture 3" descr="05_独立验证结果.png"/>
+          <p:cNvPr id="4" name="Picture 3" descr="s12_噪声结果.png"/>
           <p:cNvPicPr>
             <a:picLocks noChangeAspect="1"/>
           </p:cNvPicPr>
@@ -6791,8 +4789,8 @@
         </p:blipFill>
         <p:spPr>
           <a:xfrm>
-            <a:off x="1999648" y="914400"/>
-            <a:ext cx="8162223" cy="4846320"/>
+            <a:off x="274319" y="990785"/>
+            <a:ext cx="11640312" cy="4739269"/>
           </a:xfrm>
           <a:prstGeom prst="rect">
             <a:avLst/>
@@ -6807,8 +4805,8 @@
         </p:nvSpPr>
         <p:spPr>
           <a:xfrm>
-            <a:off x="640080" y="5897880"/>
-            <a:ext cx="10972800" cy="731520"/>
+            <a:off x="640080" y="5989320"/>
+            <a:ext cx="10881360" cy="548640"/>
           </a:xfrm>
           <a:prstGeom prst="rect">
             <a:avLst/>
@@ -6821,14 +4819,14 @@
           </a:bodyPr>
           <a:lstStyle/>
           <a:p>
-            <a:pPr algn="l"/>
-            <a:r>
-              <a:rPr sz="1300" b="0">
+            <a:pPr algn="ctr"/>
+            <a:r>
+              <a:rPr sz="1400">
                 <a:solidFill>
                   <a:srgbClr val="666666"/>
                 </a:solidFill>
               </a:rPr>
-              <a:t>结果：三波形俘获率均为 2000/2000 = 1.0000（Wilson 95% CI [0.9981, 1.0000]），配对差全部为 0，末态激发均值≈0.025。功-能残差与保持段误差远低于 1e-3 验收阈值。</a:t>
+              <a:t>默认 ×1 注入 ≤ 0.2 μK：v95 逐点不变（40.8 mm/s）；×100 无显著移动（42.6，CI 重叠）；×1000 全程 &lt; 0.95，@55 mm/s 俘获率 0.50，其中仅参量通道（0.477）≈ 三通道（0.477），仅反冲/仅指向仍 1.00。</a:t>
             </a:r>
           </a:p>
         </p:txBody>
@@ -6860,7 +4858,7 @@
         <p:spPr>
           <a:xfrm>
             <a:off x="0" y="0"/>
-            <a:ext cx="12191695" cy="868680"/>
+            <a:ext cx="12191695" cy="786384"/>
           </a:xfrm>
           <a:prstGeom prst="rect">
             <a:avLst/>
@@ -6902,8 +4900,8 @@
         </p:nvSpPr>
         <p:spPr>
           <a:xfrm>
-            <a:off x="457200" y="109728"/>
-            <a:ext cx="11338560" cy="548640"/>
+            <a:off x="457200" y="91440"/>
+            <a:ext cx="11338560" cy="603504"/>
           </a:xfrm>
           <a:prstGeom prst="rect">
             <a:avLst/>
@@ -6916,21 +4914,20 @@
           </a:bodyPr>
           <a:lstStyle/>
           <a:p>
-            <a:pPr algn="l"/>
-            <a:r>
-              <a:rPr sz="2600" b="1">
+            <a:r>
+              <a:rPr sz="2500" b="1">
                 <a:solidFill>
                   <a:srgbClr val="FFFFFF"/>
                 </a:solidFill>
               </a:rPr>
-              <a:t>蒙特卡洛初态与末态分布</a:t>
+              <a:t>最高速度测算：硬件条件下的 v95（噪声 ×1）</a:t>
             </a:r>
           </a:p>
         </p:txBody>
       </p:sp>
       <p:pic>
         <p:nvPicPr>
-          <p:cNvPr id="4" name="Picture 3" descr="06_初态与末态分布.png"/>
+          <p:cNvPr id="4" name="Picture 3" descr="s13_最高速度测算.png"/>
           <p:cNvPicPr>
             <a:picLocks noChangeAspect="1"/>
           </p:cNvPicPr>
@@ -6944,8 +4941,8 @@
         </p:blipFill>
         <p:spPr>
           <a:xfrm>
-            <a:off x="228600" y="1664207"/>
-            <a:ext cx="11704320" cy="3803904"/>
+            <a:off x="274319" y="990785"/>
+            <a:ext cx="11640312" cy="4739269"/>
           </a:xfrm>
           <a:prstGeom prst="rect">
             <a:avLst/>
@@ -6960,8 +4957,8 @@
         </p:nvSpPr>
         <p:spPr>
           <a:xfrm>
-            <a:off x="640080" y="6217920"/>
-            <a:ext cx="10972800" cy="457200"/>
+            <a:off x="640080" y="5989320"/>
+            <a:ext cx="10881360" cy="548640"/>
           </a:xfrm>
           <a:prstGeom prst="rect">
             <a:avLst/>
@@ -6974,14 +4971,14 @@
           </a:bodyPr>
           <a:lstStyle/>
           <a:p>
-            <a:pPr algn="l"/>
-            <a:r>
-              <a:rPr sz="1300" b="0">
+            <a:pPr algn="ctr"/>
+            <a:r>
+              <a:rPr sz="1400">
                 <a:solidFill>
                   <a:srgbClr val="666666"/>
                 </a:solidFill>
               </a:rPr>
-              <a:t>左：5 μK 热初态相空间（集中于 AOD 阱底附近）；右：末态位置集中于 SLM 阱（0 μm）内。</a:t>
+              <a:t>v95 随 AOD 深度按 √D 缩放（140/280/560 μK → 29.6/41.8/58.1 mm/s），η95 ≈ 0.29 与深度无关（v_ad ∝ √D）；束腰收窄到 0.90 μm 提速到 54.9 mm/s（阱更硬），放宽到 1.50 μm 降到 38.4 mm/s。</a:t>
             </a:r>
           </a:p>
         </p:txBody>

</xml_diff>